<commit_message>
vissim: say in the deck that Vissim has no junction object
Two slides in the VISSIM section. Vissim stores links and connectors and
nothing else; the segment nodes it builds on import are polygons that
swallow part of every approach, so they cannot say which links are the
interior and stay a cross-check rather than a key.

The second slide lays the four id spaces side by side for the same ten
intersections, which is what makes the naming trap concrete: our column
said _Vissim while holding the OpenDRIVE id, the mirror of the SUMO
table's *_OpenDrive columns holding SUMO ids.

Co-Authored-By: Claude Opus 5 <noreply@anthropic.com>
</commit_message>
<xml_diff>
--- a/vissim/MatchupTable_SUMO_vs_VISSIM.pptx
+++ b/vissim/MatchupTable_SUMO_vs_VISSIM.pptx
@@ -24,6 +24,8 @@
     <p:sldId id="272" r:id="rId24"/>
     <p:sldId id="273" r:id="rId25"/>
     <p:sldId id="274" r:id="rId26"/>
+    <p:sldId id="275" r:id="rId27"/>
+    <p:sldId id="276" r:id="rId28"/>
   </p:sldIdLst>
   <p:sldSz cx="12191695" cy="6858000" type="screen4x3"/>
   <p:notesSz cx="6858000" cy="9144000"/>
@@ -590,7 +592,7 @@
           <a:lstStyle/>
           <a:p>
             <a:r>
-              <a:t>RealTwin's SUMO flow asks for exactly the same 13. This is not a Vissim limitation - it is the irreducible human input. Six of Chattanooga's ten junctions carry a camera file; the other four are minor nodes and are left blank in both tables.</a:t>
+              <a:t>Both failures were on approaches where nothing was straighter, so SUMO's 44 degree band kept them as through movements while a 20 degree cut did not. A naive 'straightest wins' rule is worse, not better: it scores 100/104, because at a T-junction with no through movement it promotes a genuine 89 degree right turn to thru. The conjunction of both tests is what works.</a:t>
             </a:r>
           </a:p>
         </p:txBody>
@@ -660,7 +662,7 @@
           <a:lstStyle/>
           <a:p>
             <a:r>
-              <a:t>This is why the junction coordinates matter more than the seeding does. For a new corridor there is nothing to copy from, so the artefact that helps is junction_locations.csv: every junction with its latitude, longitude and a map link, so you can see which intersection you are filling in.</a:t>
+              <a:t>Deliberately the same sort order as the SUMO table so the two can be read side by side. Columns A-N are positionally identical; a Vissim-only column recording the junction-internal links a movement crosses is parked at the end.</a:t>
             </a:r>
           </a:p>
         </p:txBody>
@@ -730,7 +732,7 @@
           <a:lstStyle/>
           <a:p>
             <a:r>
-              <a:t>The mapping was already being written to &lt;name&gt;_junctions.csv - stage 2 simply never read it. netconvert writes the SUMO junction id into the OpenDRIVE junction's name attribute, which is where the translation comes from. Seeding went from 3 junctions to 6, and derived codes from 32 to 80.</a:t>
+              <a:t>RealTwin's SUMO flow asks for exactly the same 13. This is not a Vissim limitation - it is the irreducible human input. Six of Chattanooga's ten junctions carry a camera file; the other four are minor nodes and are left blank in both tables.</a:t>
             </a:r>
           </a:p>
         </p:txBody>
@@ -800,7 +802,7 @@
           <a:lstStyle/>
           <a:p>
             <a:r>
-              <a:t>The one real difference is the ID space, which is why the junction mapping exists as an artefact.</a:t>
+              <a:t>This is why the junction coordinates matter more than the seeding does. For a new corridor there is nothing to copy from, so the artefact that helps is junction_locations.csv: every junction with its latitude, longitude and a map link, so you can see which intersection you are filling in.</a:t>
             </a:r>
           </a:p>
         </p:txBody>
@@ -870,7 +872,7 @@
           <a:lstStyle/>
           <a:p>
             <a:r>
-              <a:t>The mapping was checked geometrically as well as by id: for all ten junctions the mapped SUMO junction is the nearest one, and the runner-up is between 9 and 686 times further away. The camera file assignment also transfers 10 of 10, with the same four junctions deliberately blank in both.</a:t>
+              <a:t>The mapping was already being written to &lt;name&gt;_junctions.csv - stage 2 simply never read it. netconvert writes the SUMO junction id into the OpenDRIVE junction's name attribute, which is where the translation comes from. Seeding went from 3 junctions to 6, and derived codes from 32 to 80.</a:t>
             </a:r>
           </a:p>
         </p:txBody>
@@ -940,6 +942,146 @@
           <a:lstStyle/>
           <a:p>
             <a:r>
+              <a:t>The one real difference is the ID space, which is why the junction mapping exists as an artefact.</a:t>
+            </a:r>
+          </a:p>
+        </p:txBody>
+      </p:sp>
+      <p:sp>
+        <p:nvSpPr>
+          <p:cNvPr id="4" name="Slide Number Placeholder 3"/>
+          <p:cNvSpPr>
+            <a:spLocks noGrp="1"/>
+          </p:cNvSpPr>
+          <p:nvPr>
+            <p:ph type="sldNum" idx="5" sz="quarter"/>
+          </p:nvPr>
+        </p:nvSpPr>
+        <p:spPr/>
+      </p:sp>
+    </p:spTree>
+  </p:cSld>
+  <p:clrMapOvr>
+    <a:masterClrMapping/>
+  </p:clrMapOvr>
+</p:notes>
+</file>
+
+<file path=ppt/notesSlides/notesSlide16.xml><?xml version="1.0" encoding="utf-8"?>
+<p:notes xmlns:a="http://schemas.openxmlformats.org/drawingml/2006/main" xmlns:p="http://schemas.openxmlformats.org/presentationml/2006/main" xmlns:r="http://schemas.openxmlformats.org/officeDocument/2006/relationships">
+  <p:cSld>
+    <p:spTree>
+      <p:nvGrpSpPr>
+        <p:cNvPr id="1" name=""/>
+        <p:cNvGrpSpPr/>
+        <p:nvPr/>
+      </p:nvGrpSpPr>
+      <p:grpSpPr>
+        <a:xfrm>
+          <a:off x="0" y="0"/>
+          <a:ext cx="0" cy="0"/>
+          <a:chOff x="0" y="0"/>
+          <a:chExt cx="0" cy="0"/>
+        </a:xfrm>
+      </p:grpSpPr>
+      <p:sp>
+        <p:nvSpPr>
+          <p:cNvPr id="2" name="Slide Image Placeholder 1"/>
+          <p:cNvSpPr>
+            <a:spLocks noGrp="1"/>
+          </p:cNvSpPr>
+          <p:nvPr>
+            <p:ph type="sldImg" idx="2"/>
+          </p:nvPr>
+        </p:nvSpPr>
+        <p:spPr/>
+      </p:sp>
+      <p:sp>
+        <p:nvSpPr>
+          <p:cNvPr id="3" name="Notes Placeholder 2"/>
+          <p:cNvSpPr>
+            <a:spLocks noGrp="1"/>
+          </p:cNvSpPr>
+          <p:nvPr>
+            <p:ph type="body" idx="3" sz="quarter"/>
+          </p:nvPr>
+        </p:nvSpPr>
+        <p:spPr/>
+        <p:txBody>
+          <a:bodyPr/>
+          <a:lstStyle/>
+          <a:p>
+            <a:r>
+              <a:t>The mapping was checked geometrically as well as by id: for all ten junctions the mapped SUMO junction is the nearest one, and the runner-up is between 9 and 686 times further away. The camera file assignment also transfers 10 of 10, with the same four junctions deliberately blank in both.</a:t>
+            </a:r>
+          </a:p>
+        </p:txBody>
+      </p:sp>
+      <p:sp>
+        <p:nvSpPr>
+          <p:cNvPr id="4" name="Slide Number Placeholder 3"/>
+          <p:cNvSpPr>
+            <a:spLocks noGrp="1"/>
+          </p:cNvSpPr>
+          <p:nvPr>
+            <p:ph type="sldNum" idx="5" sz="quarter"/>
+          </p:nvPr>
+        </p:nvSpPr>
+        <p:spPr/>
+      </p:sp>
+    </p:spTree>
+  </p:cSld>
+  <p:clrMapOvr>
+    <a:masterClrMapping/>
+  </p:clrMapOvr>
+</p:notes>
+</file>
+
+<file path=ppt/notesSlides/notesSlide17.xml><?xml version="1.0" encoding="utf-8"?>
+<p:notes xmlns:a="http://schemas.openxmlformats.org/drawingml/2006/main" xmlns:p="http://schemas.openxmlformats.org/presentationml/2006/main" xmlns:r="http://schemas.openxmlformats.org/officeDocument/2006/relationships">
+  <p:cSld>
+    <p:spTree>
+      <p:nvGrpSpPr>
+        <p:cNvPr id="1" name=""/>
+        <p:cNvGrpSpPr/>
+        <p:nvPr/>
+      </p:nvGrpSpPr>
+      <p:grpSpPr>
+        <a:xfrm>
+          <a:off x="0" y="0"/>
+          <a:ext cx="0" cy="0"/>
+          <a:chOff x="0" y="0"/>
+          <a:chExt cx="0" cy="0"/>
+        </a:xfrm>
+      </p:grpSpPr>
+      <p:sp>
+        <p:nvSpPr>
+          <p:cNvPr id="2" name="Slide Image Placeholder 1"/>
+          <p:cNvSpPr>
+            <a:spLocks noGrp="1"/>
+          </p:cNvSpPr>
+          <p:nvPr>
+            <p:ph type="sldImg" idx="2"/>
+          </p:nvPr>
+        </p:nvSpPr>
+        <p:spPr/>
+      </p:sp>
+      <p:sp>
+        <p:nvSpPr>
+          <p:cNvPr id="3" name="Notes Placeholder 2"/>
+          <p:cNvSpPr>
+            <a:spLocks noGrp="1"/>
+          </p:cNvSpPr>
+          <p:nvPr>
+            <p:ph type="body" idx="3" sz="quarter"/>
+          </p:nvPr>
+        </p:nvSpPr>
+        <p:spPr/>
+        <p:txBody>
+          <a:bodyPr/>
+          <a:lstStyle/>
+          <a:p>
+            <a:r>
               <a:t>junction_locations.csv is the one that matters for a new corridor: it needs no SUMO network at all.</a:t>
             </a:r>
           </a:p>
@@ -1360,7 +1502,7 @@
           <a:lstStyle/>
           <a:p>
             <a:r>
-              <a:t>Chattanooga: 441 Vissim objects = 186 links + 255 connectors. Of the 186 links, 127 are junction-internal and 59 are ordinary roads.</a:t>
+              <a:t>check_nodes_against_junctions compares the derived grouping against Vissim's own nodes and reports any junction present in one and not the other. The Vissim manual notes it 'adopts the name and ID' of each OpenDRIVE junction, so the two readings share a precondition and disagreement is worth knowing about.</a:t>
             </a:r>
           </a:p>
         </p:txBody>
@@ -1430,7 +1572,7 @@
           <a:lstStyle/>
           <a:p>
             <a:r>
-              <a:t>Both failures were on approaches where nothing was straighter, so SUMO's 44 degree band kept them as through movements while a 20 degree cut did not. A naive 'straightest wins' rule is worse, not better: it scores 100/104, because at a T-junction with no through movement it promotes a genuine 89 degree right turn to thru. The conjunction of both tests is what works.</a:t>
+              <a:t>Vissim node names encode the OpenDRIVE junction: node No=1 is named '11: 10', meaning OpenDRIVE junction 11 whose name is SUMO junction 10. Our MatchupTable column was called JunctionID_Vissim, which implied the first column; it has always held the second, and is now named JunctionID_OpenDrive. The same trap as the SUMO table's *_OpenDrive columns, in the other direction.</a:t>
             </a:r>
           </a:p>
         </p:txBody>
@@ -1500,7 +1642,7 @@
           <a:lstStyle/>
           <a:p>
             <a:r>
-              <a:t>Deliberately the same sort order as the SUMO table so the two can be read side by side. Columns A-N are positionally identical; a Vissim-only column recording the junction-internal links a movement crosses is parked at the end.</a:t>
+              <a:t>Chattanooga: 441 Vissim objects = 186 links + 255 connectors. Of the 186 links, 127 are junction-internal and 59 are ordinary roads.</a:t>
             </a:r>
           </a:p>
         </p:txBody>
@@ -4724,7 +4866,7 @@
                 </a:solidFill>
                 <a:latin typeface="Calibri"/>
               </a:rPr>
-              <a:t>From links to movements</a:t>
+              <a:t>Vissim has no junction object</a:t>
             </a:r>
           </a:p>
         </p:txBody>
@@ -4753,257 +4895,97 @@
           <a:p>
             <a:pPr>
               <a:spcAft>
-                <a:spcPts val="200"/>
-              </a:spcAft>
-            </a:pPr>
-            <a:r>
-              <a:rPr sz="1500" b="0">
+                <a:spcPts val="1000"/>
+              </a:spcAft>
+            </a:pPr>
+            <a:r>
+              <a:rPr sz="1800" b="0">
                 <a:solidFill>
                   <a:srgbClr val="1A1A1A"/>
                 </a:solidFill>
-                <a:latin typeface="Consolas"/>
-              </a:rPr>
-              <a:t>junction 15  -&gt;  interior Vissim links {101, 102, 103, 104}</a:t>
+                <a:latin typeface="Calibri"/>
+              </a:rPr>
+              <a:t>• Vissim stores links and connectors. There is no intersection object at all</a:t>
             </a:r>
           </a:p>
           <a:p>
             <a:pPr>
               <a:spcAft>
-                <a:spcPts val="200"/>
-              </a:spcAft>
-            </a:pPr>
-            <a:r>
-              <a:rPr sz="1500" b="0">
+                <a:spcPts val="1000"/>
+              </a:spcAft>
+            </a:pPr>
+            <a:r>
+              <a:rPr sz="1800" b="0">
                 <a:solidFill>
                   <a:srgbClr val="1A1A1A"/>
                 </a:solidFill>
-                <a:latin typeface="Consolas"/>
-              </a:rPr>
-              <a:t/>
+                <a:latin typeface="Calibri"/>
+              </a:rPr>
+              <a:t>• It does build one segment node per junction on import - 17 of them here</a:t>
+            </a:r>
+          </a:p>
+          <a:p>
+            <a:pPr lvl="1">
+              <a:spcAft>
+                <a:spcPts val="1000"/>
+              </a:spcAft>
+            </a:pPr>
+            <a:r>
+              <a:rPr sz="1600" b="0">
+                <a:solidFill>
+                  <a:srgbClr val="5A5A5A"/>
+                </a:solidFill>
+                <a:latin typeface="Calibri"/>
+              </a:rPr>
+              <a:t>but a node is a POLYGON, so it swallows part of every approach too:</a:t>
+            </a:r>
+          </a:p>
+          <a:p>
+            <a:pPr lvl="1">
+              <a:spcAft>
+                <a:spcPts val="1000"/>
+              </a:spcAft>
+            </a:pPr>
+            <a:r>
+              <a:rPr sz="1600" b="0">
+                <a:solidFill>
+                  <a:srgbClr val="5A5A5A"/>
+                </a:solidFill>
+                <a:latin typeface="Calibri"/>
+              </a:rPr>
+              <a:t>25 links at the largest junction against the 17 genuinely interior ones</a:t>
+            </a:r>
+          </a:p>
+          <a:p>
+            <a:pPr lvl="1">
+              <a:spcAft>
+                <a:spcPts val="1000"/>
+              </a:spcAft>
+            </a:pPr>
+            <a:r>
+              <a:rPr sz="1600" b="0">
+                <a:solidFill>
+                  <a:srgbClr val="5A5A5A"/>
+                </a:solidFill>
+                <a:latin typeface="Calibri"/>
+              </a:rPr>
+              <a:t>it cannot say which links are the interior, which is what we need</a:t>
             </a:r>
           </a:p>
           <a:p>
             <a:pPr>
               <a:spcAft>
-                <a:spcPts val="200"/>
-              </a:spcAft>
-            </a:pPr>
-            <a:r>
-              <a:rPr sz="1500" b="0">
+                <a:spcPts val="1000"/>
+              </a:spcAft>
+            </a:pPr>
+            <a:r>
+              <a:rPr sz="1800" b="0">
                 <a:solidFill>
                   <a:srgbClr val="1A1A1A"/>
                 </a:solidFill>
-                <a:latin typeface="Consolas"/>
-              </a:rPr>
-              <a:t>  APPROACHES - links feeding an interior link from OUTSIDE the group</a:t>
-            </a:r>
-          </a:p>
-          <a:p>
-            <a:pPr lvl="1">
-              <a:spcAft>
-                <a:spcPts val="200"/>
-              </a:spcAft>
-            </a:pPr>
-            <a:r>
-              <a:rPr sz="1300" b="0">
-                <a:solidFill>
-                  <a:srgbClr val="5A5A5A"/>
-                </a:solidFill>
-                <a:latin typeface="Consolas"/>
-              </a:rPr>
-              <a:t>link 27 --conn--&gt; 103        27 is outside  -&gt; approach</a:t>
-            </a:r>
-          </a:p>
-          <a:p>
-            <a:pPr lvl="1">
-              <a:spcAft>
-                <a:spcPts val="200"/>
-              </a:spcAft>
-            </a:pPr>
-            <a:r>
-              <a:rPr sz="1300" b="0">
-                <a:solidFill>
-                  <a:srgbClr val="5A5A5A"/>
-                </a:solidFill>
-                <a:latin typeface="Consolas"/>
-              </a:rPr>
-              <a:t>link 41 --conn--&gt; 101        41 is outside  -&gt; approach</a:t>
-            </a:r>
-          </a:p>
-          <a:p>
-            <a:pPr lvl="1">
-              <a:spcAft>
-                <a:spcPts val="200"/>
-              </a:spcAft>
-            </a:pPr>
-            <a:r>
-              <a:rPr sz="1300" b="0">
-                <a:solidFill>
-                  <a:srgbClr val="5A5A5A"/>
-                </a:solidFill>
-                <a:latin typeface="Consolas"/>
-              </a:rPr>
-              <a:t>link 46 --conn--&gt; 102        46 is outside  -&gt; approach</a:t>
-            </a:r>
-          </a:p>
-          <a:p>
-            <a:pPr lvl="1">
-              <a:spcAft>
-                <a:spcPts val="200"/>
-              </a:spcAft>
-            </a:pPr>
-            <a:r>
-              <a:rPr sz="1300" b="0">
-                <a:solidFill>
-                  <a:srgbClr val="5A5A5A"/>
-                </a:solidFill>
-                <a:latin typeface="Consolas"/>
-              </a:rPr>
-              <a:t>101 --conn--&gt; link 47        leaving        -&gt; exit, not an approach</a:t>
-            </a:r>
-          </a:p>
-          <a:p>
-            <a:pPr>
-              <a:spcAft>
-                <a:spcPts val="200"/>
-              </a:spcAft>
-            </a:pPr>
-            <a:r>
-              <a:rPr sz="1500" b="0">
-                <a:solidFill>
-                  <a:srgbClr val="1A1A1A"/>
-                </a:solidFill>
-                <a:latin typeface="Consolas"/>
-              </a:rPr>
-              <a:t/>
-            </a:r>
-          </a:p>
-          <a:p>
-            <a:pPr>
-              <a:spcAft>
-                <a:spcPts val="200"/>
-              </a:spcAft>
-            </a:pPr>
-            <a:r>
-              <a:rPr sz="1500" b="0">
-                <a:solidFill>
-                  <a:srgbClr val="1A1A1A"/>
-                </a:solidFill>
-                <a:latin typeface="Consolas"/>
-              </a:rPr>
-              <a:t>  FILTER - fewer than 3 approaches is a mid-block joint, not an intersection</a:t>
-            </a:r>
-          </a:p>
-          <a:p>
-            <a:pPr lvl="1">
-              <a:spcAft>
-                <a:spcPts val="200"/>
-              </a:spcAft>
-            </a:pPr>
-            <a:r>
-              <a:rPr sz="1300" b="0">
-                <a:solidFill>
-                  <a:srgbClr val="5A5A5A"/>
-                </a:solidFill>
-                <a:latin typeface="Consolas"/>
-              </a:rPr>
-              <a:t>17 groups  -&gt;  10 real intersections</a:t>
-            </a:r>
-          </a:p>
-          <a:p>
-            <a:pPr>
-              <a:spcAft>
-                <a:spcPts val="200"/>
-              </a:spcAft>
-            </a:pPr>
-            <a:r>
-              <a:rPr sz="1500" b="0">
-                <a:solidFill>
-                  <a:srgbClr val="1A1A1A"/>
-                </a:solidFill>
-                <a:latin typeface="Consolas"/>
-              </a:rPr>
-              <a:t/>
-            </a:r>
-          </a:p>
-          <a:p>
-            <a:pPr>
-              <a:spcAft>
-                <a:spcPts val="200"/>
-              </a:spcAft>
-            </a:pPr>
-            <a:r>
-              <a:rPr sz="1500" b="0">
-                <a:solidFill>
-                  <a:srgbClr val="1A1A1A"/>
-                </a:solidFill>
-                <a:latin typeface="Consolas"/>
-              </a:rPr>
-              <a:t>  MOVEMENTS - walk each approach through the interior to every exit</a:t>
-            </a:r>
-          </a:p>
-          <a:p>
-            <a:pPr lvl="1">
-              <a:spcAft>
-                <a:spcPts val="200"/>
-              </a:spcAft>
-            </a:pPr>
-            <a:r>
-              <a:rPr sz="1300" b="0">
-                <a:solidFill>
-                  <a:srgbClr val="5A5A5A"/>
-                </a:solidFill>
-                <a:latin typeface="Consolas"/>
-              </a:rPr>
-              <a:t>46 -&gt; [102] -&gt; 49      27 -&gt; [103] -&gt; 50</a:t>
-            </a:r>
-          </a:p>
-          <a:p>
-            <a:pPr lvl="1">
-              <a:spcAft>
-                <a:spcPts val="200"/>
-              </a:spcAft>
-            </a:pPr>
-            <a:r>
-              <a:rPr sz="1300" b="0">
-                <a:solidFill>
-                  <a:srgbClr val="5A5A5A"/>
-                </a:solidFill>
-                <a:latin typeface="Consolas"/>
-              </a:rPr>
-              <a:t>27 -&gt; [104] -&gt; 49      41 -&gt; [101] -&gt; 47</a:t>
-            </a:r>
-          </a:p>
-          <a:p>
-            <a:pPr>
-              <a:spcAft>
-                <a:spcPts val="200"/>
-              </a:spcAft>
-            </a:pPr>
-            <a:r>
-              <a:rPr sz="1500" b="0">
-                <a:solidFill>
-                  <a:srgbClr val="1A1A1A"/>
-                </a:solidFill>
-                <a:latin typeface="Consolas"/>
-              </a:rPr>
-              <a:t/>
-            </a:r>
-          </a:p>
-          <a:p>
-            <a:pPr>
-              <a:spcAft>
-                <a:spcPts val="200"/>
-              </a:spcAft>
-            </a:pPr>
-            <a:r>
-              <a:rPr sz="1500" b="0">
-                <a:solidFill>
-                  <a:srgbClr val="1A1A1A"/>
-                </a:solidFill>
-                <a:latin typeface="Consolas"/>
-              </a:rPr>
-              <a:t>  34 approaches  -&gt;  104 movements</a:t>
+                <a:latin typeface="Calibri"/>
+              </a:rPr>
+              <a:t>• So we use it as a cross-check, never as the key. The id we carry is OpenDRIVE's</a:t>
             </a:r>
           </a:p>
         </p:txBody>
@@ -5104,146 +5086,869 @@
                 </a:solidFill>
                 <a:latin typeface="Calibri"/>
               </a:rPr>
-              <a:t>Turns - the same rule SUMO uses</a:t>
-            </a:r>
-          </a:p>
-        </p:txBody>
-      </p:sp>
-      <p:sp>
-        <p:nvSpPr>
-          <p:cNvPr id="4" name="TextBox 3"/>
-          <p:cNvSpPr txBox="1"/>
+              <a:t>Four ID spaces, the same ten intersections</a:t>
+            </a:r>
+          </a:p>
+        </p:txBody>
+      </p:sp>
+      <p:graphicFrame>
+        <p:nvGraphicFramePr>
+          <p:cNvPr id="4" name="Table 3"/>
+          <p:cNvGraphicFramePr>
+            <a:graphicFrameLocks noGrp="1"/>
+          </p:cNvGraphicFramePr>
           <p:nvPr/>
-        </p:nvSpPr>
-        <p:spPr>
-          <a:xfrm>
-            <a:off x="640080" y="1325880"/>
-            <a:ext cx="10972800" cy="5120640"/>
-          </a:xfrm>
-          <a:prstGeom prst="rect">
-            <a:avLst/>
-          </a:prstGeom>
-          <a:noFill/>
-        </p:spPr>
-        <p:txBody>
-          <a:bodyPr wrap="square">
-            <a:spAutoFit/>
-          </a:bodyPr>
-          <a:lstStyle/>
-          <a:p>
-            <a:pPr>
-              <a:spcAft>
-                <a:spcPts val="1000"/>
-              </a:spcAft>
-            </a:pPr>
-            <a:r>
-              <a:rPr sz="1800" b="0">
-                <a:solidFill>
-                  <a:srgbClr val="1A1A1A"/>
-                </a:solidFill>
-                <a:latin typeface="Calibri"/>
-              </a:rPr>
-              <a:t>• A turn cannot be classified from its own angle alone</a:t>
-            </a:r>
-          </a:p>
-          <a:p>
-            <a:pPr>
-              <a:spcAft>
-                <a:spcPts val="1000"/>
-              </a:spcAft>
-            </a:pPr>
-            <a:r>
-              <a:rPr sz="1800" b="0">
-                <a:solidFill>
-                  <a:srgbClr val="1A1A1A"/>
-                </a:solidFill>
-                <a:latin typeface="Calibri"/>
-              </a:rPr>
-              <a:t>• SUMO's NBNode::getDirection, which is what wrote those dir attributes:</a:t>
-            </a:r>
-          </a:p>
-          <a:p>
-            <a:pPr lvl="1">
-              <a:spcAft>
-                <a:spcPts val="1000"/>
-              </a:spcAft>
-            </a:pPr>
-            <a:r>
-              <a:rPr sz="1600" b="0">
-                <a:solidFill>
-                  <a:srgbClr val="5A5A5A"/>
-                </a:solidFill>
-                <a:latin typeface="Calibri"/>
-              </a:rPr>
-              <a:t>inside 44 deg -&gt; straight, UNLESS another movement off the approach is straighter</a:t>
-            </a:r>
-          </a:p>
-          <a:p>
-            <a:pPr lvl="1">
-              <a:spcAft>
-                <a:spcPts val="1000"/>
-              </a:spcAft>
-            </a:pPr>
-            <a:r>
-              <a:rPr sz="1600" b="0">
-                <a:solidFill>
-                  <a:srgbClr val="5A5A5A"/>
-                </a:solidFill>
-                <a:latin typeface="Calibri"/>
-              </a:rPr>
-              <a:t>beyond 44 deg -&gt; left or right      U-turn is decided structurally</a:t>
-            </a:r>
-          </a:p>
-          <a:p>
-            <a:pPr>
-              <a:spcAft>
-                <a:spcPts val="1000"/>
-              </a:spcAft>
-            </a:pPr>
-            <a:r>
-              <a:rPr sz="1800" b="0">
-                <a:solidFill>
-                  <a:srgbClr val="1A1A1A"/>
-                </a:solidFill>
-                <a:latin typeface="Calibri"/>
-              </a:rPr>
-              <a:t>• We previously used a symmetric 20 deg cut, and it broke on two skewed approaches</a:t>
-            </a:r>
-          </a:p>
-          <a:p>
-            <a:pPr lvl="1">
-              <a:spcAft>
-                <a:spcPts val="1000"/>
-              </a:spcAft>
-            </a:pPr>
-            <a:r>
-              <a:rPr sz="1600" b="0">
-                <a:solidFill>
-                  <a:srgbClr val="5A5A5A"/>
-                </a:solidFill>
-                <a:latin typeface="Calibri"/>
-              </a:rPr>
-              <a:t>-21.3 and -28.4 deg were called left; SUMO calls both thru</a:t>
-            </a:r>
-          </a:p>
-          <a:p>
-            <a:pPr>
-              <a:spcAft>
-                <a:spcPts val="1000"/>
-              </a:spcAft>
-            </a:pPr>
-            <a:r>
-              <a:rPr sz="1800" b="0">
-                <a:solidFill>
-                  <a:srgbClr val="1A1A1A"/>
-                </a:solidFill>
-                <a:latin typeface="Calibri"/>
-              </a:rPr>
-              <a:t>• Porting the real rule took the movement table from 102/104 to 104/104</a:t>
-            </a:r>
-          </a:p>
-        </p:txBody>
-      </p:sp>
+        </p:nvGraphicFramePr>
+        <p:xfrm>
+          <a:off x="548640" y="1371600"/>
+          <a:ext cx="11064240" cy="4023360"/>
+        </p:xfrm>
+        <a:graphic>
+          <a:graphicData uri="http://schemas.openxmlformats.org/drawingml/2006/table">
+            <a:tbl>
+              <a:tblPr firstRow="1" bandRow="1">
+                <a:tableStyleId>{5C22544A-7EE6-4342-B048-85BDC9FD1C3A}</a:tableStyleId>
+              </a:tblPr>
+              <a:tblGrid>
+                <a:gridCol w="2377440"/>
+                <a:gridCol w="2651760"/>
+                <a:gridCol w="2377440"/>
+                <a:gridCol w="3657600"/>
+              </a:tblGrid>
+              <a:tr h="365760">
+                <a:tc>
+                  <a:txBody>
+                    <a:bodyPr/>
+                    <a:lstStyle/>
+                    <a:p>
+                      <a:r>
+                        <a:rPr sz="1400" b="1">
+                          <a:solidFill>
+                            <a:srgbClr val="FFFFFF"/>
+                          </a:solidFill>
+                          <a:latin typeface="Calibri"/>
+                        </a:rPr>
+                        <a:t>Vissim node No</a:t>
+                      </a:r>
+                    </a:p>
+                  </a:txBody>
+                  <a:tcPr>
+                    <a:solidFill>
+                      <a:srgbClr val="14375E"/>
+                    </a:solidFill>
+                  </a:tcPr>
+                </a:tc>
+                <a:tc>
+                  <a:txBody>
+                    <a:bodyPr/>
+                    <a:lstStyle/>
+                    <a:p>
+                      <a:r>
+                        <a:rPr sz="1400" b="1">
+                          <a:solidFill>
+                            <a:srgbClr val="FFFFFF"/>
+                          </a:solidFill>
+                          <a:latin typeface="Calibri"/>
+                        </a:rPr>
+                        <a:t>OpenDRIVE junction</a:t>
+                      </a:r>
+                    </a:p>
+                  </a:txBody>
+                  <a:tcPr>
+                    <a:solidFill>
+                      <a:srgbClr val="14375E"/>
+                    </a:solidFill>
+                  </a:tcPr>
+                </a:tc>
+                <a:tc>
+                  <a:txBody>
+                    <a:bodyPr/>
+                    <a:lstStyle/>
+                    <a:p>
+                      <a:r>
+                        <a:rPr sz="1400" b="1">
+                          <a:solidFill>
+                            <a:srgbClr val="FFFFFF"/>
+                          </a:solidFill>
+                          <a:latin typeface="Calibri"/>
+                        </a:rPr>
+                        <a:t>SUMO junction</a:t>
+                      </a:r>
+                    </a:p>
+                  </a:txBody>
+                  <a:tcPr>
+                    <a:solidFill>
+                      <a:srgbClr val="14375E"/>
+                    </a:solidFill>
+                  </a:tcPr>
+                </a:tc>
+                <a:tc>
+                  <a:txBody>
+                    <a:bodyPr/>
+                    <a:lstStyle/>
+                    <a:p>
+                      <a:r>
+                        <a:rPr sz="1400" b="1">
+                          <a:solidFill>
+                            <a:srgbClr val="FFFFFF"/>
+                          </a:solidFill>
+                          <a:latin typeface="Calibri"/>
+                        </a:rPr>
+                        <a:t>Vissim approach links</a:t>
+                      </a:r>
+                    </a:p>
+                  </a:txBody>
+                  <a:tcPr>
+                    <a:solidFill>
+                      <a:srgbClr val="14375E"/>
+                    </a:solidFill>
+                  </a:tcPr>
+                </a:tc>
+              </a:tr>
+              <a:tr h="365760">
+                <a:tc>
+                  <a:txBody>
+                    <a:bodyPr/>
+                    <a:lstStyle/>
+                    <a:p>
+                      <a:r>
+                        <a:rPr sz="1200" b="0">
+                          <a:solidFill>
+                            <a:srgbClr val="1A1A1A"/>
+                          </a:solidFill>
+                          <a:latin typeface="Calibri"/>
+                        </a:rPr>
+                        <a:t>5</a:t>
+                      </a:r>
+                    </a:p>
+                  </a:txBody>
+                  <a:tcPr/>
+                </a:tc>
+                <a:tc>
+                  <a:txBody>
+                    <a:bodyPr/>
+                    <a:lstStyle/>
+                    <a:p>
+                      <a:r>
+                        <a:rPr sz="1200" b="0">
+                          <a:solidFill>
+                            <a:srgbClr val="1A1A1A"/>
+                          </a:solidFill>
+                          <a:latin typeface="Calibri"/>
+                        </a:rPr>
+                        <a:t>2</a:t>
+                      </a:r>
+                    </a:p>
+                  </a:txBody>
+                  <a:tcPr/>
+                </a:tc>
+                <a:tc>
+                  <a:txBody>
+                    <a:bodyPr/>
+                    <a:lstStyle/>
+                    <a:p>
+                      <a:r>
+                        <a:rPr sz="1200" b="0">
+                          <a:solidFill>
+                            <a:srgbClr val="1A1A1A"/>
+                          </a:solidFill>
+                          <a:latin typeface="Calibri"/>
+                        </a:rPr>
+                        <a:t>2</a:t>
+                      </a:r>
+                    </a:p>
+                  </a:txBody>
+                  <a:tcPr/>
+                </a:tc>
+                <a:tc>
+                  <a:txBody>
+                    <a:bodyPr/>
+                    <a:lstStyle/>
+                    <a:p>
+                      <a:r>
+                        <a:rPr sz="1200" b="0">
+                          <a:solidFill>
+                            <a:srgbClr val="1A1A1A"/>
+                          </a:solidFill>
+                          <a:latin typeface="Calibri"/>
+                        </a:rPr>
+                        <a:t>1  33  53  56</a:t>
+                      </a:r>
+                    </a:p>
+                  </a:txBody>
+                  <a:tcPr/>
+                </a:tc>
+              </a:tr>
+              <a:tr h="365760">
+                <a:tc>
+                  <a:txBody>
+                    <a:bodyPr/>
+                    <a:lstStyle/>
+                    <a:p>
+                      <a:r>
+                        <a:rPr sz="1200" b="0">
+                          <a:solidFill>
+                            <a:srgbClr val="1A1A1A"/>
+                          </a:solidFill>
+                          <a:latin typeface="Calibri"/>
+                        </a:rPr>
+                        <a:t>6</a:t>
+                      </a:r>
+                    </a:p>
+                  </a:txBody>
+                  <a:tcPr/>
+                </a:tc>
+                <a:tc>
+                  <a:txBody>
+                    <a:bodyPr/>
+                    <a:lstStyle/>
+                    <a:p>
+                      <a:r>
+                        <a:rPr sz="1200" b="0">
+                          <a:solidFill>
+                            <a:srgbClr val="1A1A1A"/>
+                          </a:solidFill>
+                          <a:latin typeface="Calibri"/>
+                        </a:rPr>
+                        <a:t>4</a:t>
+                      </a:r>
+                    </a:p>
+                  </a:txBody>
+                  <a:tcPr/>
+                </a:tc>
+                <a:tc>
+                  <a:txBody>
+                    <a:bodyPr/>
+                    <a:lstStyle/>
+                    <a:p>
+                      <a:r>
+                        <a:rPr sz="1200" b="0">
+                          <a:solidFill>
+                            <a:srgbClr val="1A1A1A"/>
+                          </a:solidFill>
+                          <a:latin typeface="Calibri"/>
+                        </a:rPr>
+                        <a:t>3</a:t>
+                      </a:r>
+                    </a:p>
+                  </a:txBody>
+                  <a:tcPr/>
+                </a:tc>
+                <a:tc>
+                  <a:txBody>
+                    <a:bodyPr/>
+                    <a:lstStyle/>
+                    <a:p>
+                      <a:r>
+                        <a:rPr sz="1200" b="0">
+                          <a:solidFill>
+                            <a:srgbClr val="1A1A1A"/>
+                          </a:solidFill>
+                          <a:latin typeface="Calibri"/>
+                        </a:rPr>
+                        <a:t>38  43  44  55</a:t>
+                      </a:r>
+                    </a:p>
+                  </a:txBody>
+                  <a:tcPr/>
+                </a:tc>
+              </a:tr>
+              <a:tr h="365760">
+                <a:tc>
+                  <a:txBody>
+                    <a:bodyPr/>
+                    <a:lstStyle/>
+                    <a:p>
+                      <a:r>
+                        <a:rPr sz="1200" b="0">
+                          <a:solidFill>
+                            <a:srgbClr val="1A1A1A"/>
+                          </a:solidFill>
+                          <a:latin typeface="Calibri"/>
+                        </a:rPr>
+                        <a:t>7</a:t>
+                      </a:r>
+                    </a:p>
+                  </a:txBody>
+                  <a:tcPr/>
+                </a:tc>
+                <a:tc>
+                  <a:txBody>
+                    <a:bodyPr/>
+                    <a:lstStyle/>
+                    <a:p>
+                      <a:r>
+                        <a:rPr sz="1200" b="0">
+                          <a:solidFill>
+                            <a:srgbClr val="1A1A1A"/>
+                          </a:solidFill>
+                          <a:latin typeface="Calibri"/>
+                        </a:rPr>
+                        <a:t>5</a:t>
+                      </a:r>
+                    </a:p>
+                  </a:txBody>
+                  <a:tcPr/>
+                </a:tc>
+                <a:tc>
+                  <a:txBody>
+                    <a:bodyPr/>
+                    <a:lstStyle/>
+                    <a:p>
+                      <a:r>
+                        <a:rPr sz="1200" b="0">
+                          <a:solidFill>
+                            <a:srgbClr val="1A1A1A"/>
+                          </a:solidFill>
+                          <a:latin typeface="Calibri"/>
+                        </a:rPr>
+                        <a:t>4</a:t>
+                      </a:r>
+                    </a:p>
+                  </a:txBody>
+                  <a:tcPr/>
+                </a:tc>
+                <a:tc>
+                  <a:txBody>
+                    <a:bodyPr/>
+                    <a:lstStyle/>
+                    <a:p>
+                      <a:r>
+                        <a:rPr sz="1200" b="0">
+                          <a:solidFill>
+                            <a:srgbClr val="1A1A1A"/>
+                          </a:solidFill>
+                          <a:latin typeface="Calibri"/>
+                        </a:rPr>
+                        <a:t>3  42  48</a:t>
+                      </a:r>
+                    </a:p>
+                  </a:txBody>
+                  <a:tcPr/>
+                </a:tc>
+              </a:tr>
+              <a:tr h="365760">
+                <a:tc>
+                  <a:txBody>
+                    <a:bodyPr/>
+                    <a:lstStyle/>
+                    <a:p>
+                      <a:r>
+                        <a:rPr sz="1200" b="0">
+                          <a:solidFill>
+                            <a:srgbClr val="1A1A1A"/>
+                          </a:solidFill>
+                          <a:latin typeface="Calibri"/>
+                        </a:rPr>
+                        <a:t>8</a:t>
+                      </a:r>
+                    </a:p>
+                  </a:txBody>
+                  <a:tcPr/>
+                </a:tc>
+                <a:tc>
+                  <a:txBody>
+                    <a:bodyPr/>
+                    <a:lstStyle/>
+                    <a:p>
+                      <a:r>
+                        <a:rPr sz="1200" b="0">
+                          <a:solidFill>
+                            <a:srgbClr val="1A1A1A"/>
+                          </a:solidFill>
+                          <a:latin typeface="Calibri"/>
+                        </a:rPr>
+                        <a:t>7</a:t>
+                      </a:r>
+                    </a:p>
+                  </a:txBody>
+                  <a:tcPr/>
+                </a:tc>
+                <a:tc>
+                  <a:txBody>
+                    <a:bodyPr/>
+                    <a:lstStyle/>
+                    <a:p>
+                      <a:r>
+                        <a:rPr sz="1200" b="0">
+                          <a:solidFill>
+                            <a:srgbClr val="1A1A1A"/>
+                          </a:solidFill>
+                          <a:latin typeface="Calibri"/>
+                        </a:rPr>
+                        <a:t>7</a:t>
+                      </a:r>
+                    </a:p>
+                  </a:txBody>
+                  <a:tcPr/>
+                </a:tc>
+                <a:tc>
+                  <a:txBody>
+                    <a:bodyPr/>
+                    <a:lstStyle/>
+                    <a:p>
+                      <a:r>
+                        <a:rPr sz="1200" b="0">
+                          <a:solidFill>
+                            <a:srgbClr val="1A1A1A"/>
+                          </a:solidFill>
+                          <a:latin typeface="Calibri"/>
+                        </a:rPr>
+                        <a:t>7  32  58</a:t>
+                      </a:r>
+                    </a:p>
+                  </a:txBody>
+                  <a:tcPr/>
+                </a:tc>
+              </a:tr>
+              <a:tr h="365760">
+                <a:tc>
+                  <a:txBody>
+                    <a:bodyPr/>
+                    <a:lstStyle/>
+                    <a:p>
+                      <a:r>
+                        <a:rPr sz="1200" b="0">
+                          <a:solidFill>
+                            <a:srgbClr val="1A1A1A"/>
+                          </a:solidFill>
+                          <a:latin typeface="Calibri"/>
+                        </a:rPr>
+                        <a:t>10</a:t>
+                      </a:r>
+                    </a:p>
+                  </a:txBody>
+                  <a:tcPr/>
+                </a:tc>
+                <a:tc>
+                  <a:txBody>
+                    <a:bodyPr/>
+                    <a:lstStyle/>
+                    <a:p>
+                      <a:r>
+                        <a:rPr sz="1200" b="0">
+                          <a:solidFill>
+                            <a:srgbClr val="1A1A1A"/>
+                          </a:solidFill>
+                          <a:latin typeface="Calibri"/>
+                        </a:rPr>
+                        <a:t>9</a:t>
+                      </a:r>
+                    </a:p>
+                  </a:txBody>
+                  <a:tcPr/>
+                </a:tc>
+                <a:tc>
+                  <a:txBody>
+                    <a:bodyPr/>
+                    <a:lstStyle/>
+                    <a:p>
+                      <a:r>
+                        <a:rPr sz="1200" b="0">
+                          <a:solidFill>
+                            <a:srgbClr val="1A1A1A"/>
+                          </a:solidFill>
+                          <a:latin typeface="Calibri"/>
+                        </a:rPr>
+                        <a:t>9</a:t>
+                      </a:r>
+                    </a:p>
+                  </a:txBody>
+                  <a:tcPr/>
+                </a:tc>
+                <a:tc>
+                  <a:txBody>
+                    <a:bodyPr/>
+                    <a:lstStyle/>
+                    <a:p>
+                      <a:r>
+                        <a:rPr sz="1200" b="0">
+                          <a:solidFill>
+                            <a:srgbClr val="1A1A1A"/>
+                          </a:solidFill>
+                          <a:latin typeface="Calibri"/>
+                        </a:rPr>
+                        <a:t>8  17  22</a:t>
+                      </a:r>
+                    </a:p>
+                  </a:txBody>
+                  <a:tcPr/>
+                </a:tc>
+              </a:tr>
+              <a:tr h="365760">
+                <a:tc>
+                  <a:txBody>
+                    <a:bodyPr/>
+                    <a:lstStyle/>
+                    <a:p>
+                      <a:r>
+                        <a:rPr sz="1200" b="0">
+                          <a:solidFill>
+                            <a:srgbClr val="1A1A1A"/>
+                          </a:solidFill>
+                          <a:latin typeface="Calibri"/>
+                        </a:rPr>
+                        <a:t>9</a:t>
+                      </a:r>
+                    </a:p>
+                  </a:txBody>
+                  <a:tcPr/>
+                </a:tc>
+                <a:tc>
+                  <a:txBody>
+                    <a:bodyPr/>
+                    <a:lstStyle/>
+                    <a:p>
+                      <a:r>
+                        <a:rPr sz="1200" b="0">
+                          <a:solidFill>
+                            <a:srgbClr val="1A1A1A"/>
+                          </a:solidFill>
+                          <a:latin typeface="Calibri"/>
+                        </a:rPr>
+                        <a:t>10</a:t>
+                      </a:r>
+                    </a:p>
+                  </a:txBody>
+                  <a:tcPr/>
+                </a:tc>
+                <a:tc>
+                  <a:txBody>
+                    <a:bodyPr/>
+                    <a:lstStyle/>
+                    <a:p>
+                      <a:r>
+                        <a:rPr sz="1200" b="0">
+                          <a:solidFill>
+                            <a:srgbClr val="1A1A1A"/>
+                          </a:solidFill>
+                          <a:latin typeface="Calibri"/>
+                        </a:rPr>
+                        <a:t>8</a:t>
+                      </a:r>
+                    </a:p>
+                  </a:txBody>
+                  <a:tcPr/>
+                </a:tc>
+                <a:tc>
+                  <a:txBody>
+                    <a:bodyPr/>
+                    <a:lstStyle/>
+                    <a:p>
+                      <a:r>
+                        <a:rPr sz="1200" b="0">
+                          <a:solidFill>
+                            <a:srgbClr val="1A1A1A"/>
+                          </a:solidFill>
+                          <a:latin typeface="Calibri"/>
+                        </a:rPr>
+                        <a:t>13  25  35</a:t>
+                      </a:r>
+                    </a:p>
+                  </a:txBody>
+                  <a:tcPr/>
+                </a:tc>
+              </a:tr>
+              <a:tr h="365760">
+                <a:tc>
+                  <a:txBody>
+                    <a:bodyPr/>
+                    <a:lstStyle/>
+                    <a:p>
+                      <a:r>
+                        <a:rPr sz="1200" b="0">
+                          <a:solidFill>
+                            <a:srgbClr val="1A1A1A"/>
+                          </a:solidFill>
+                          <a:latin typeface="Calibri"/>
+                        </a:rPr>
+                        <a:t>1</a:t>
+                      </a:r>
+                    </a:p>
+                  </a:txBody>
+                  <a:tcPr/>
+                </a:tc>
+                <a:tc>
+                  <a:txBody>
+                    <a:bodyPr/>
+                    <a:lstStyle/>
+                    <a:p>
+                      <a:r>
+                        <a:rPr sz="1200" b="0">
+                          <a:solidFill>
+                            <a:srgbClr val="1A1A1A"/>
+                          </a:solidFill>
+                          <a:latin typeface="Calibri"/>
+                        </a:rPr>
+                        <a:t>11</a:t>
+                      </a:r>
+                    </a:p>
+                  </a:txBody>
+                  <a:tcPr/>
+                </a:tc>
+                <a:tc>
+                  <a:txBody>
+                    <a:bodyPr/>
+                    <a:lstStyle/>
+                    <a:p>
+                      <a:r>
+                        <a:rPr sz="1200" b="0">
+                          <a:solidFill>
+                            <a:srgbClr val="1A1A1A"/>
+                          </a:solidFill>
+                          <a:latin typeface="Calibri"/>
+                        </a:rPr>
+                        <a:t>10</a:t>
+                      </a:r>
+                    </a:p>
+                  </a:txBody>
+                  <a:tcPr/>
+                </a:tc>
+                <a:tc>
+                  <a:txBody>
+                    <a:bodyPr/>
+                    <a:lstStyle/>
+                    <a:p>
+                      <a:r>
+                        <a:rPr sz="1200" b="0">
+                          <a:solidFill>
+                            <a:srgbClr val="1A1A1A"/>
+                          </a:solidFill>
+                          <a:latin typeface="Calibri"/>
+                        </a:rPr>
+                        <a:t>10  45  47  52</a:t>
+                      </a:r>
+                    </a:p>
+                  </a:txBody>
+                  <a:tcPr/>
+                </a:tc>
+              </a:tr>
+              <a:tr h="365760">
+                <a:tc>
+                  <a:txBody>
+                    <a:bodyPr/>
+                    <a:lstStyle/>
+                    <a:p>
+                      <a:r>
+                        <a:rPr sz="1200" b="0">
+                          <a:solidFill>
+                            <a:srgbClr val="1A1A1A"/>
+                          </a:solidFill>
+                          <a:latin typeface="Calibri"/>
+                        </a:rPr>
+                        <a:t>2</a:t>
+                      </a:r>
+                    </a:p>
+                  </a:txBody>
+                  <a:tcPr/>
+                </a:tc>
+                <a:tc>
+                  <a:txBody>
+                    <a:bodyPr/>
+                    <a:lstStyle/>
+                    <a:p>
+                      <a:r>
+                        <a:rPr sz="1200" b="0">
+                          <a:solidFill>
+                            <a:srgbClr val="1A1A1A"/>
+                          </a:solidFill>
+                          <a:latin typeface="Calibri"/>
+                        </a:rPr>
+                        <a:t>13</a:t>
+                      </a:r>
+                    </a:p>
+                  </a:txBody>
+                  <a:tcPr/>
+                </a:tc>
+                <a:tc>
+                  <a:txBody>
+                    <a:bodyPr/>
+                    <a:lstStyle/>
+                    <a:p>
+                      <a:r>
+                        <a:rPr sz="1200" b="0">
+                          <a:solidFill>
+                            <a:srgbClr val="1A1A1A"/>
+                          </a:solidFill>
+                          <a:latin typeface="Calibri"/>
+                        </a:rPr>
+                        <a:t>11</a:t>
+                      </a:r>
+                    </a:p>
+                  </a:txBody>
+                  <a:tcPr/>
+                </a:tc>
+                <a:tc>
+                  <a:txBody>
+                    <a:bodyPr/>
+                    <a:lstStyle/>
+                    <a:p>
+                      <a:r>
+                        <a:rPr sz="1200" b="0">
+                          <a:solidFill>
+                            <a:srgbClr val="1A1A1A"/>
+                          </a:solidFill>
+                          <a:latin typeface="Calibri"/>
+                        </a:rPr>
+                        <a:t>15  18  59</a:t>
+                      </a:r>
+                    </a:p>
+                  </a:txBody>
+                  <a:tcPr/>
+                </a:tc>
+              </a:tr>
+              <a:tr h="365760">
+                <a:tc>
+                  <a:txBody>
+                    <a:bodyPr/>
+                    <a:lstStyle/>
+                    <a:p>
+                      <a:r>
+                        <a:rPr sz="1200" b="0">
+                          <a:solidFill>
+                            <a:srgbClr val="1A1A1A"/>
+                          </a:solidFill>
+                          <a:latin typeface="Calibri"/>
+                        </a:rPr>
+                        <a:t>3</a:t>
+                      </a:r>
+                    </a:p>
+                  </a:txBody>
+                  <a:tcPr/>
+                </a:tc>
+                <a:tc>
+                  <a:txBody>
+                    <a:bodyPr/>
+                    <a:lstStyle/>
+                    <a:p>
+                      <a:r>
+                        <a:rPr sz="1200" b="0">
+                          <a:solidFill>
+                            <a:srgbClr val="1A1A1A"/>
+                          </a:solidFill>
+                          <a:latin typeface="Calibri"/>
+                        </a:rPr>
+                        <a:t>14</a:t>
+                      </a:r>
+                    </a:p>
+                  </a:txBody>
+                  <a:tcPr/>
+                </a:tc>
+                <a:tc>
+                  <a:txBody>
+                    <a:bodyPr/>
+                    <a:lstStyle/>
+                    <a:p>
+                      <a:r>
+                        <a:rPr sz="1200" b="0">
+                          <a:solidFill>
+                            <a:srgbClr val="1A1A1A"/>
+                          </a:solidFill>
+                          <a:latin typeface="Calibri"/>
+                        </a:rPr>
+                        <a:t>12</a:t>
+                      </a:r>
+                    </a:p>
+                  </a:txBody>
+                  <a:tcPr/>
+                </a:tc>
+                <a:tc>
+                  <a:txBody>
+                    <a:bodyPr/>
+                    <a:lstStyle/>
+                    <a:p>
+                      <a:r>
+                        <a:rPr sz="1200" b="0">
+                          <a:solidFill>
+                            <a:srgbClr val="1A1A1A"/>
+                          </a:solidFill>
+                          <a:latin typeface="Calibri"/>
+                        </a:rPr>
+                        <a:t>23  34  37  51</a:t>
+                      </a:r>
+                    </a:p>
+                  </a:txBody>
+                  <a:tcPr/>
+                </a:tc>
+              </a:tr>
+              <a:tr h="365760">
+                <a:tc>
+                  <a:txBody>
+                    <a:bodyPr/>
+                    <a:lstStyle/>
+                    <a:p>
+                      <a:r>
+                        <a:rPr sz="1200" b="0">
+                          <a:solidFill>
+                            <a:srgbClr val="1A1A1A"/>
+                          </a:solidFill>
+                          <a:latin typeface="Calibri"/>
+                        </a:rPr>
+                        <a:t>4</a:t>
+                      </a:r>
+                    </a:p>
+                  </a:txBody>
+                  <a:tcPr/>
+                </a:tc>
+                <a:tc>
+                  <a:txBody>
+                    <a:bodyPr/>
+                    <a:lstStyle/>
+                    <a:p>
+                      <a:r>
+                        <a:rPr sz="1200" b="0">
+                          <a:solidFill>
+                            <a:srgbClr val="1A1A1A"/>
+                          </a:solidFill>
+                          <a:latin typeface="Calibri"/>
+                        </a:rPr>
+                        <a:t>15</a:t>
+                      </a:r>
+                    </a:p>
+                  </a:txBody>
+                  <a:tcPr/>
+                </a:tc>
+                <a:tc>
+                  <a:txBody>
+                    <a:bodyPr/>
+                    <a:lstStyle/>
+                    <a:p>
+                      <a:r>
+                        <a:rPr sz="1200" b="0">
+                          <a:solidFill>
+                            <a:srgbClr val="1A1A1A"/>
+                          </a:solidFill>
+                          <a:latin typeface="Calibri"/>
+                        </a:rPr>
+                        <a:t>18</a:t>
+                      </a:r>
+                    </a:p>
+                  </a:txBody>
+                  <a:tcPr/>
+                </a:tc>
+                <a:tc>
+                  <a:txBody>
+                    <a:bodyPr/>
+                    <a:lstStyle/>
+                    <a:p>
+                      <a:r>
+                        <a:rPr sz="1200" b="0">
+                          <a:solidFill>
+                            <a:srgbClr val="1A1A1A"/>
+                          </a:solidFill>
+                          <a:latin typeface="Calibri"/>
+                        </a:rPr>
+                        <a:t>27  41  46</a:t>
+                      </a:r>
+                    </a:p>
+                  </a:txBody>
+                  <a:tcPr/>
+                </a:tc>
+              </a:tr>
+            </a:tbl>
+          </a:graphicData>
+        </a:graphic>
+      </p:graphicFrame>
     </p:spTree>
   </p:cSld>
   <p:clrMapOvr>
@@ -5340,7 +6045,7 @@
                 </a:solidFill>
                 <a:latin typeface="Calibri"/>
               </a:rPr>
-              <a:t>How the Vissim table is assembled</a:t>
+              <a:t>From links to movements</a:t>
             </a:r>
           </a:p>
         </p:txBody>
@@ -5379,7 +6084,39 @@
                 </a:solidFill>
                 <a:latin typeface="Consolas"/>
               </a:rPr>
-              <a:t>chatt.net.xml  -&gt;  netconvert  -&gt;  chatt.xodr  -&gt;  Vissim COM import</a:t>
+              <a:t>junction 15  -&gt;  interior Vissim links {101, 102, 103, 104}</a:t>
+            </a:r>
+          </a:p>
+          <a:p>
+            <a:pPr>
+              <a:spcAft>
+                <a:spcPts val="200"/>
+              </a:spcAft>
+            </a:pPr>
+            <a:r>
+              <a:rPr sz="1500" b="0">
+                <a:solidFill>
+                  <a:srgbClr val="1A1A1A"/>
+                </a:solidFill>
+                <a:latin typeface="Consolas"/>
+              </a:rPr>
+              <a:t/>
+            </a:r>
+          </a:p>
+          <a:p>
+            <a:pPr>
+              <a:spcAft>
+                <a:spcPts val="200"/>
+              </a:spcAft>
+            </a:pPr>
+            <a:r>
+              <a:rPr sz="1500" b="0">
+                <a:solidFill>
+                  <a:srgbClr val="1A1A1A"/>
+                </a:solidFill>
+                <a:latin typeface="Consolas"/>
+              </a:rPr>
+              <a:t>  APPROACHES - links feeding an interior link from OUTSIDE the group</a:t>
             </a:r>
           </a:p>
           <a:p>
@@ -5395,7 +6132,7 @@
                 </a:solidFill>
                 <a:latin typeface="Consolas"/>
               </a:rPr>
-              <a:t>|</a:t>
+              <a:t>link 27 --conn--&gt; 103        27 is outside  -&gt; approach</a:t>
             </a:r>
           </a:p>
           <a:p>
@@ -5411,7 +6148,7 @@
                 </a:solidFill>
                 <a:latin typeface="Consolas"/>
               </a:rPr>
-              <a:t>+-- match each Vissim link to its OpenDRIVE road by geometry</a:t>
+              <a:t>link 41 --conn--&gt; 101        41 is outside  -&gt; approach</a:t>
             </a:r>
           </a:p>
           <a:p>
@@ -5427,7 +6164,7 @@
                 </a:solidFill>
                 <a:latin typeface="Consolas"/>
               </a:rPr>
-              <a:t>|      -&gt; the road's junction attribute gives the junction</a:t>
+              <a:t>link 46 --conn--&gt; 102        46 is outside  -&gt; approach</a:t>
             </a:r>
           </a:p>
           <a:p>
@@ -5443,7 +6180,39 @@
                 </a:solidFill>
                 <a:latin typeface="Consolas"/>
               </a:rPr>
-              <a:t>|</a:t>
+              <a:t>101 --conn--&gt; link 47        leaving        -&gt; exit, not an approach</a:t>
+            </a:r>
+          </a:p>
+          <a:p>
+            <a:pPr>
+              <a:spcAft>
+                <a:spcPts val="200"/>
+              </a:spcAft>
+            </a:pPr>
+            <a:r>
+              <a:rPr sz="1500" b="0">
+                <a:solidFill>
+                  <a:srgbClr val="1A1A1A"/>
+                </a:solidFill>
+                <a:latin typeface="Consolas"/>
+              </a:rPr>
+              <a:t/>
+            </a:r>
+          </a:p>
+          <a:p>
+            <a:pPr>
+              <a:spcAft>
+                <a:spcPts val="200"/>
+              </a:spcAft>
+            </a:pPr>
+            <a:r>
+              <a:rPr sz="1500" b="0">
+                <a:solidFill>
+                  <a:srgbClr val="1A1A1A"/>
+                </a:solidFill>
+                <a:latin typeface="Consolas"/>
+              </a:rPr>
+              <a:t>  FILTER - fewer than 3 approaches is a mid-block joint, not an intersection</a:t>
             </a:r>
           </a:p>
           <a:p>
@@ -5459,7 +6228,39 @@
                 </a:solidFill>
                 <a:latin typeface="Consolas"/>
               </a:rPr>
-              <a:t>+-- approaches from the connectors, filtered at 3 legs</a:t>
+              <a:t>17 groups  -&gt;  10 real intersections</a:t>
+            </a:r>
+          </a:p>
+          <a:p>
+            <a:pPr>
+              <a:spcAft>
+                <a:spcPts val="200"/>
+              </a:spcAft>
+            </a:pPr>
+            <a:r>
+              <a:rPr sz="1500" b="0">
+                <a:solidFill>
+                  <a:srgbClr val="1A1A1A"/>
+                </a:solidFill>
+                <a:latin typeface="Consolas"/>
+              </a:rPr>
+              <a:t/>
+            </a:r>
+          </a:p>
+          <a:p>
+            <a:pPr>
+              <a:spcAft>
+                <a:spcPts val="200"/>
+              </a:spcAft>
+            </a:pPr>
+            <a:r>
+              <a:rPr sz="1500" b="0">
+                <a:solidFill>
+                  <a:srgbClr val="1A1A1A"/>
+                </a:solidFill>
+                <a:latin typeface="Consolas"/>
+              </a:rPr>
+              <a:t>  MOVEMENTS - walk each approach through the interior to every exit</a:t>
             </a:r>
           </a:p>
           <a:p>
@@ -5475,7 +6276,7 @@
                 </a:solidFill>
                 <a:latin typeface="Consolas"/>
               </a:rPr>
-              <a:t>|</a:t>
+              <a:t>46 -&gt; [102] -&gt; 49      27 -&gt; [103] -&gt; 50</a:t>
             </a:r>
           </a:p>
           <a:p>
@@ -5491,135 +6292,39 @@
                 </a:solidFill>
                 <a:latin typeface="Consolas"/>
               </a:rPr>
-              <a:t>+-- bearings from the Vissim link polylines</a:t>
-            </a:r>
-          </a:p>
-          <a:p>
-            <a:pPr lvl="1">
+              <a:t>27 -&gt; [104] -&gt; 49      41 -&gt; [101] -&gt; 47</a:t>
+            </a:r>
+          </a:p>
+          <a:p>
+            <a:pPr>
               <a:spcAft>
                 <a:spcPts val="200"/>
               </a:spcAft>
             </a:pPr>
             <a:r>
-              <a:rPr sz="1300" b="0">
-                <a:solidFill>
-                  <a:srgbClr val="5A5A5A"/>
+              <a:rPr sz="1500" b="0">
+                <a:solidFill>
+                  <a:srgbClr val="1A1A1A"/>
                 </a:solidFill>
                 <a:latin typeface="Consolas"/>
               </a:rPr>
-              <a:t>|      approach: last two points   exit: first two points</a:t>
-            </a:r>
-          </a:p>
-          <a:p>
-            <a:pPr lvl="1">
+              <a:t/>
+            </a:r>
+          </a:p>
+          <a:p>
+            <a:pPr>
               <a:spcAft>
                 <a:spcPts val="200"/>
               </a:spcAft>
             </a:pPr>
             <a:r>
-              <a:rPr sz="1300" b="0">
-                <a:solidFill>
-                  <a:srgbClr val="5A5A5A"/>
+              <a:rPr sz="1500" b="0">
+                <a:solidFill>
+                  <a:srgbClr val="1A1A1A"/>
                 </a:solidFill>
                 <a:latin typeface="Consolas"/>
               </a:rPr>
-              <a:t>|</a:t>
-            </a:r>
-          </a:p>
-          <a:p>
-            <a:pPr lvl="1">
-              <a:spcAft>
-                <a:spcPts val="200"/>
-              </a:spcAft>
-            </a:pPr>
-            <a:r>
-              <a:rPr sz="1300" b="0">
-                <a:solidFill>
-                  <a:srgbClr val="5A5A5A"/>
-                </a:solidFill>
-                <a:latin typeface="Consolas"/>
-              </a:rPr>
-              <a:t>+-- turns by SUMO's rule, per approach</a:t>
-            </a:r>
-          </a:p>
-          <a:p>
-            <a:pPr lvl="1">
-              <a:spcAft>
-                <a:spcPts val="200"/>
-              </a:spcAft>
-            </a:pPr>
-            <a:r>
-              <a:rPr sz="1300" b="0">
-                <a:solidFill>
-                  <a:srgbClr val="5A5A5A"/>
-                </a:solidFill>
-                <a:latin typeface="Consolas"/>
-              </a:rPr>
-              <a:t>|</a:t>
-            </a:r>
-          </a:p>
-          <a:p>
-            <a:pPr lvl="1">
-              <a:spcAft>
-                <a:spcPts val="200"/>
-              </a:spcAft>
-            </a:pPr>
-            <a:r>
-              <a:rPr sz="1300" b="0">
-                <a:solidFill>
-                  <a:srgbClr val="5A5A5A"/>
-                </a:solidFill>
-                <a:latin typeface="Consolas"/>
-              </a:rPr>
-              <a:t>+-- sorted by junction, bearing from 337.5 deg, then turn</a:t>
-            </a:r>
-          </a:p>
-          <a:p>
-            <a:pPr lvl="1">
-              <a:spcAft>
-                <a:spcPts val="200"/>
-              </a:spcAft>
-            </a:pPr>
-            <a:r>
-              <a:rPr sz="1300" b="0">
-                <a:solidFill>
-                  <a:srgbClr val="5A5A5A"/>
-                </a:solidFill>
-                <a:latin typeface="Consolas"/>
-              </a:rPr>
-              <a:t>|</a:t>
-            </a:r>
-          </a:p>
-          <a:p>
-            <a:pPr lvl="1">
-              <a:spcAft>
-                <a:spcPts val="200"/>
-              </a:spcAft>
-            </a:pPr>
-            <a:r>
-              <a:rPr sz="1300" b="0">
-                <a:solidFill>
-                  <a:srgbClr val="5A5A5A"/>
-                </a:solidFill>
-                <a:latin typeface="Consolas"/>
-              </a:rPr>
-              <a:t>v</a:t>
-            </a:r>
-          </a:p>
-          <a:p>
-            <a:pPr>
-              <a:spcAft>
-                <a:spcPts val="200"/>
-              </a:spcAft>
-            </a:pPr>
-            <a:r>
-              <a:rPr sz="1500" b="0">
-                <a:solidFill>
-                  <a:srgbClr val="1A1A1A"/>
-                </a:solidFill>
-                <a:latin typeface="Consolas"/>
-              </a:rPr>
-              <a:t>MatchupTable.xlsx        demand and signal columns BLANK</a:t>
+              <a:t>  34 approaches  -&gt;  104 movements</a:t>
             </a:r>
           </a:p>
         </p:txBody>
@@ -5633,6 +6338,622 @@
 </file>
 
 <file path=ppt/slides/slide13.xml><?xml version="1.0" encoding="utf-8"?>
+<p:sld xmlns:a="http://schemas.openxmlformats.org/drawingml/2006/main" xmlns:p="http://schemas.openxmlformats.org/presentationml/2006/main" xmlns:r="http://schemas.openxmlformats.org/officeDocument/2006/relationships">
+  <p:cSld>
+    <p:spTree>
+      <p:nvGrpSpPr>
+        <p:cNvPr id="1" name=""/>
+        <p:cNvGrpSpPr/>
+        <p:nvPr/>
+      </p:nvGrpSpPr>
+      <p:grpSpPr/>
+      <p:sp>
+        <p:nvSpPr>
+          <p:cNvPr id="2" name="Rectangle 1"/>
+          <p:cNvSpPr/>
+          <p:nvPr/>
+        </p:nvSpPr>
+        <p:spPr>
+          <a:xfrm>
+            <a:off x="0" y="0"/>
+            <a:ext cx="12191695" cy="1005840"/>
+          </a:xfrm>
+          <a:prstGeom prst="rect">
+            <a:avLst/>
+          </a:prstGeom>
+          <a:solidFill>
+            <a:srgbClr val="14375E"/>
+          </a:solidFill>
+          <a:ln>
+            <a:noFill/>
+          </a:ln>
+          <a:effectLst/>
+        </p:spPr>
+        <p:style>
+          <a:lnRef idx="1">
+            <a:schemeClr val="accent1"/>
+          </a:lnRef>
+          <a:fillRef idx="3">
+            <a:schemeClr val="accent1"/>
+          </a:fillRef>
+          <a:effectRef idx="2">
+            <a:schemeClr val="accent1"/>
+          </a:effectRef>
+          <a:fontRef idx="minor">
+            <a:schemeClr val="lt1"/>
+          </a:fontRef>
+        </p:style>
+        <p:txBody>
+          <a:bodyPr rtlCol="0" anchor="ctr"/>
+          <a:lstStyle/>
+          <a:p>
+            <a:pPr algn="ctr"/>
+          </a:p>
+        </p:txBody>
+      </p:sp>
+      <p:sp>
+        <p:nvSpPr>
+          <p:cNvPr id="3" name="TextBox 2"/>
+          <p:cNvSpPr txBox="1"/>
+          <p:nvPr/>
+        </p:nvSpPr>
+        <p:spPr>
+          <a:xfrm>
+            <a:off x="457200" y="164592"/>
+            <a:ext cx="11247120" cy="731520"/>
+          </a:xfrm>
+          <a:prstGeom prst="rect">
+            <a:avLst/>
+          </a:prstGeom>
+          <a:noFill/>
+        </p:spPr>
+        <p:txBody>
+          <a:bodyPr wrap="square">
+            <a:spAutoFit/>
+          </a:bodyPr>
+          <a:lstStyle/>
+          <a:p>
+            <a:pPr>
+              <a:spcAft>
+                <a:spcPts val="1000"/>
+              </a:spcAft>
+            </a:pPr>
+            <a:r>
+              <a:rPr sz="2600" b="1">
+                <a:solidFill>
+                  <a:srgbClr val="FFFFFF"/>
+                </a:solidFill>
+                <a:latin typeface="Calibri"/>
+              </a:rPr>
+              <a:t>Turns - the same rule SUMO uses</a:t>
+            </a:r>
+          </a:p>
+        </p:txBody>
+      </p:sp>
+      <p:sp>
+        <p:nvSpPr>
+          <p:cNvPr id="4" name="TextBox 3"/>
+          <p:cNvSpPr txBox="1"/>
+          <p:nvPr/>
+        </p:nvSpPr>
+        <p:spPr>
+          <a:xfrm>
+            <a:off x="640080" y="1325880"/>
+            <a:ext cx="10972800" cy="5120640"/>
+          </a:xfrm>
+          <a:prstGeom prst="rect">
+            <a:avLst/>
+          </a:prstGeom>
+          <a:noFill/>
+        </p:spPr>
+        <p:txBody>
+          <a:bodyPr wrap="square">
+            <a:spAutoFit/>
+          </a:bodyPr>
+          <a:lstStyle/>
+          <a:p>
+            <a:pPr>
+              <a:spcAft>
+                <a:spcPts val="1000"/>
+              </a:spcAft>
+            </a:pPr>
+            <a:r>
+              <a:rPr sz="1800" b="0">
+                <a:solidFill>
+                  <a:srgbClr val="1A1A1A"/>
+                </a:solidFill>
+                <a:latin typeface="Calibri"/>
+              </a:rPr>
+              <a:t>• A turn cannot be classified from its own angle alone</a:t>
+            </a:r>
+          </a:p>
+          <a:p>
+            <a:pPr>
+              <a:spcAft>
+                <a:spcPts val="1000"/>
+              </a:spcAft>
+            </a:pPr>
+            <a:r>
+              <a:rPr sz="1800" b="0">
+                <a:solidFill>
+                  <a:srgbClr val="1A1A1A"/>
+                </a:solidFill>
+                <a:latin typeface="Calibri"/>
+              </a:rPr>
+              <a:t>• SUMO's NBNode::getDirection, which is what wrote those dir attributes:</a:t>
+            </a:r>
+          </a:p>
+          <a:p>
+            <a:pPr lvl="1">
+              <a:spcAft>
+                <a:spcPts val="1000"/>
+              </a:spcAft>
+            </a:pPr>
+            <a:r>
+              <a:rPr sz="1600" b="0">
+                <a:solidFill>
+                  <a:srgbClr val="5A5A5A"/>
+                </a:solidFill>
+                <a:latin typeface="Calibri"/>
+              </a:rPr>
+              <a:t>inside 44 deg -&gt; straight, UNLESS another movement off the approach is straighter</a:t>
+            </a:r>
+          </a:p>
+          <a:p>
+            <a:pPr lvl="1">
+              <a:spcAft>
+                <a:spcPts val="1000"/>
+              </a:spcAft>
+            </a:pPr>
+            <a:r>
+              <a:rPr sz="1600" b="0">
+                <a:solidFill>
+                  <a:srgbClr val="5A5A5A"/>
+                </a:solidFill>
+                <a:latin typeface="Calibri"/>
+              </a:rPr>
+              <a:t>beyond 44 deg -&gt; left or right      U-turn is decided structurally</a:t>
+            </a:r>
+          </a:p>
+          <a:p>
+            <a:pPr>
+              <a:spcAft>
+                <a:spcPts val="1000"/>
+              </a:spcAft>
+            </a:pPr>
+            <a:r>
+              <a:rPr sz="1800" b="0">
+                <a:solidFill>
+                  <a:srgbClr val="1A1A1A"/>
+                </a:solidFill>
+                <a:latin typeface="Calibri"/>
+              </a:rPr>
+              <a:t>• We previously used a symmetric 20 deg cut, and it broke on two skewed approaches</a:t>
+            </a:r>
+          </a:p>
+          <a:p>
+            <a:pPr lvl="1">
+              <a:spcAft>
+                <a:spcPts val="1000"/>
+              </a:spcAft>
+            </a:pPr>
+            <a:r>
+              <a:rPr sz="1600" b="0">
+                <a:solidFill>
+                  <a:srgbClr val="5A5A5A"/>
+                </a:solidFill>
+                <a:latin typeface="Calibri"/>
+              </a:rPr>
+              <a:t>-21.3 and -28.4 deg were called left; SUMO calls both thru</a:t>
+            </a:r>
+          </a:p>
+          <a:p>
+            <a:pPr>
+              <a:spcAft>
+                <a:spcPts val="1000"/>
+              </a:spcAft>
+            </a:pPr>
+            <a:r>
+              <a:rPr sz="1800" b="0">
+                <a:solidFill>
+                  <a:srgbClr val="1A1A1A"/>
+                </a:solidFill>
+                <a:latin typeface="Calibri"/>
+              </a:rPr>
+              <a:t>• Porting the real rule took the movement table from 102/104 to 104/104</a:t>
+            </a:r>
+          </a:p>
+        </p:txBody>
+      </p:sp>
+    </p:spTree>
+  </p:cSld>
+  <p:clrMapOvr>
+    <a:masterClrMapping/>
+  </p:clrMapOvr>
+</p:sld>
+</file>
+
+<file path=ppt/slides/slide14.xml><?xml version="1.0" encoding="utf-8"?>
+<p:sld xmlns:a="http://schemas.openxmlformats.org/drawingml/2006/main" xmlns:p="http://schemas.openxmlformats.org/presentationml/2006/main" xmlns:r="http://schemas.openxmlformats.org/officeDocument/2006/relationships">
+  <p:cSld>
+    <p:spTree>
+      <p:nvGrpSpPr>
+        <p:cNvPr id="1" name=""/>
+        <p:cNvGrpSpPr/>
+        <p:nvPr/>
+      </p:nvGrpSpPr>
+      <p:grpSpPr/>
+      <p:sp>
+        <p:nvSpPr>
+          <p:cNvPr id="2" name="Rectangle 1"/>
+          <p:cNvSpPr/>
+          <p:nvPr/>
+        </p:nvSpPr>
+        <p:spPr>
+          <a:xfrm>
+            <a:off x="0" y="0"/>
+            <a:ext cx="12191695" cy="1005840"/>
+          </a:xfrm>
+          <a:prstGeom prst="rect">
+            <a:avLst/>
+          </a:prstGeom>
+          <a:solidFill>
+            <a:srgbClr val="14375E"/>
+          </a:solidFill>
+          <a:ln>
+            <a:noFill/>
+          </a:ln>
+          <a:effectLst/>
+        </p:spPr>
+        <p:style>
+          <a:lnRef idx="1">
+            <a:schemeClr val="accent1"/>
+          </a:lnRef>
+          <a:fillRef idx="3">
+            <a:schemeClr val="accent1"/>
+          </a:fillRef>
+          <a:effectRef idx="2">
+            <a:schemeClr val="accent1"/>
+          </a:effectRef>
+          <a:fontRef idx="minor">
+            <a:schemeClr val="lt1"/>
+          </a:fontRef>
+        </p:style>
+        <p:txBody>
+          <a:bodyPr rtlCol="0" anchor="ctr"/>
+          <a:lstStyle/>
+          <a:p>
+            <a:pPr algn="ctr"/>
+          </a:p>
+        </p:txBody>
+      </p:sp>
+      <p:sp>
+        <p:nvSpPr>
+          <p:cNvPr id="3" name="TextBox 2"/>
+          <p:cNvSpPr txBox="1"/>
+          <p:nvPr/>
+        </p:nvSpPr>
+        <p:spPr>
+          <a:xfrm>
+            <a:off x="457200" y="164592"/>
+            <a:ext cx="11247120" cy="731520"/>
+          </a:xfrm>
+          <a:prstGeom prst="rect">
+            <a:avLst/>
+          </a:prstGeom>
+          <a:noFill/>
+        </p:spPr>
+        <p:txBody>
+          <a:bodyPr wrap="square">
+            <a:spAutoFit/>
+          </a:bodyPr>
+          <a:lstStyle/>
+          <a:p>
+            <a:pPr>
+              <a:spcAft>
+                <a:spcPts val="1000"/>
+              </a:spcAft>
+            </a:pPr>
+            <a:r>
+              <a:rPr sz="2600" b="1">
+                <a:solidFill>
+                  <a:srgbClr val="FFFFFF"/>
+                </a:solidFill>
+                <a:latin typeface="Calibri"/>
+              </a:rPr>
+              <a:t>How the Vissim table is assembled</a:t>
+            </a:r>
+          </a:p>
+        </p:txBody>
+      </p:sp>
+      <p:sp>
+        <p:nvSpPr>
+          <p:cNvPr id="4" name="TextBox 3"/>
+          <p:cNvSpPr txBox="1"/>
+          <p:nvPr/>
+        </p:nvSpPr>
+        <p:spPr>
+          <a:xfrm>
+            <a:off x="640080" y="1325880"/>
+            <a:ext cx="10972800" cy="5120640"/>
+          </a:xfrm>
+          <a:prstGeom prst="rect">
+            <a:avLst/>
+          </a:prstGeom>
+          <a:noFill/>
+        </p:spPr>
+        <p:txBody>
+          <a:bodyPr wrap="square">
+            <a:spAutoFit/>
+          </a:bodyPr>
+          <a:lstStyle/>
+          <a:p>
+            <a:pPr>
+              <a:spcAft>
+                <a:spcPts val="200"/>
+              </a:spcAft>
+            </a:pPr>
+            <a:r>
+              <a:rPr sz="1500" b="0">
+                <a:solidFill>
+                  <a:srgbClr val="1A1A1A"/>
+                </a:solidFill>
+                <a:latin typeface="Consolas"/>
+              </a:rPr>
+              <a:t>chatt.net.xml  -&gt;  netconvert  -&gt;  chatt.xodr  -&gt;  Vissim COM import</a:t>
+            </a:r>
+          </a:p>
+          <a:p>
+            <a:pPr lvl="1">
+              <a:spcAft>
+                <a:spcPts val="200"/>
+              </a:spcAft>
+            </a:pPr>
+            <a:r>
+              <a:rPr sz="1300" b="0">
+                <a:solidFill>
+                  <a:srgbClr val="5A5A5A"/>
+                </a:solidFill>
+                <a:latin typeface="Consolas"/>
+              </a:rPr>
+              <a:t>|</a:t>
+            </a:r>
+          </a:p>
+          <a:p>
+            <a:pPr lvl="1">
+              <a:spcAft>
+                <a:spcPts val="200"/>
+              </a:spcAft>
+            </a:pPr>
+            <a:r>
+              <a:rPr sz="1300" b="0">
+                <a:solidFill>
+                  <a:srgbClr val="5A5A5A"/>
+                </a:solidFill>
+                <a:latin typeface="Consolas"/>
+              </a:rPr>
+              <a:t>+-- match each Vissim link to its OpenDRIVE road by geometry</a:t>
+            </a:r>
+          </a:p>
+          <a:p>
+            <a:pPr lvl="1">
+              <a:spcAft>
+                <a:spcPts val="200"/>
+              </a:spcAft>
+            </a:pPr>
+            <a:r>
+              <a:rPr sz="1300" b="0">
+                <a:solidFill>
+                  <a:srgbClr val="5A5A5A"/>
+                </a:solidFill>
+                <a:latin typeface="Consolas"/>
+              </a:rPr>
+              <a:t>|      -&gt; the road's junction attribute gives the junction</a:t>
+            </a:r>
+          </a:p>
+          <a:p>
+            <a:pPr lvl="1">
+              <a:spcAft>
+                <a:spcPts val="200"/>
+              </a:spcAft>
+            </a:pPr>
+            <a:r>
+              <a:rPr sz="1300" b="0">
+                <a:solidFill>
+                  <a:srgbClr val="5A5A5A"/>
+                </a:solidFill>
+                <a:latin typeface="Consolas"/>
+              </a:rPr>
+              <a:t>|</a:t>
+            </a:r>
+          </a:p>
+          <a:p>
+            <a:pPr lvl="1">
+              <a:spcAft>
+                <a:spcPts val="200"/>
+              </a:spcAft>
+            </a:pPr>
+            <a:r>
+              <a:rPr sz="1300" b="0">
+                <a:solidFill>
+                  <a:srgbClr val="5A5A5A"/>
+                </a:solidFill>
+                <a:latin typeface="Consolas"/>
+              </a:rPr>
+              <a:t>+-- approaches from the connectors, filtered at 3 legs</a:t>
+            </a:r>
+          </a:p>
+          <a:p>
+            <a:pPr lvl="1">
+              <a:spcAft>
+                <a:spcPts val="200"/>
+              </a:spcAft>
+            </a:pPr>
+            <a:r>
+              <a:rPr sz="1300" b="0">
+                <a:solidFill>
+                  <a:srgbClr val="5A5A5A"/>
+                </a:solidFill>
+                <a:latin typeface="Consolas"/>
+              </a:rPr>
+              <a:t>|</a:t>
+            </a:r>
+          </a:p>
+          <a:p>
+            <a:pPr lvl="1">
+              <a:spcAft>
+                <a:spcPts val="200"/>
+              </a:spcAft>
+            </a:pPr>
+            <a:r>
+              <a:rPr sz="1300" b="0">
+                <a:solidFill>
+                  <a:srgbClr val="5A5A5A"/>
+                </a:solidFill>
+                <a:latin typeface="Consolas"/>
+              </a:rPr>
+              <a:t>+-- bearings from the Vissim link polylines</a:t>
+            </a:r>
+          </a:p>
+          <a:p>
+            <a:pPr lvl="1">
+              <a:spcAft>
+                <a:spcPts val="200"/>
+              </a:spcAft>
+            </a:pPr>
+            <a:r>
+              <a:rPr sz="1300" b="0">
+                <a:solidFill>
+                  <a:srgbClr val="5A5A5A"/>
+                </a:solidFill>
+                <a:latin typeface="Consolas"/>
+              </a:rPr>
+              <a:t>|      approach: last two points   exit: first two points</a:t>
+            </a:r>
+          </a:p>
+          <a:p>
+            <a:pPr lvl="1">
+              <a:spcAft>
+                <a:spcPts val="200"/>
+              </a:spcAft>
+            </a:pPr>
+            <a:r>
+              <a:rPr sz="1300" b="0">
+                <a:solidFill>
+                  <a:srgbClr val="5A5A5A"/>
+                </a:solidFill>
+                <a:latin typeface="Consolas"/>
+              </a:rPr>
+              <a:t>|</a:t>
+            </a:r>
+          </a:p>
+          <a:p>
+            <a:pPr lvl="1">
+              <a:spcAft>
+                <a:spcPts val="200"/>
+              </a:spcAft>
+            </a:pPr>
+            <a:r>
+              <a:rPr sz="1300" b="0">
+                <a:solidFill>
+                  <a:srgbClr val="5A5A5A"/>
+                </a:solidFill>
+                <a:latin typeface="Consolas"/>
+              </a:rPr>
+              <a:t>+-- turns by SUMO's rule, per approach</a:t>
+            </a:r>
+          </a:p>
+          <a:p>
+            <a:pPr lvl="1">
+              <a:spcAft>
+                <a:spcPts val="200"/>
+              </a:spcAft>
+            </a:pPr>
+            <a:r>
+              <a:rPr sz="1300" b="0">
+                <a:solidFill>
+                  <a:srgbClr val="5A5A5A"/>
+                </a:solidFill>
+                <a:latin typeface="Consolas"/>
+              </a:rPr>
+              <a:t>|</a:t>
+            </a:r>
+          </a:p>
+          <a:p>
+            <a:pPr lvl="1">
+              <a:spcAft>
+                <a:spcPts val="200"/>
+              </a:spcAft>
+            </a:pPr>
+            <a:r>
+              <a:rPr sz="1300" b="0">
+                <a:solidFill>
+                  <a:srgbClr val="5A5A5A"/>
+                </a:solidFill>
+                <a:latin typeface="Consolas"/>
+              </a:rPr>
+              <a:t>+-- sorted by junction, bearing from 337.5 deg, then turn</a:t>
+            </a:r>
+          </a:p>
+          <a:p>
+            <a:pPr lvl="1">
+              <a:spcAft>
+                <a:spcPts val="200"/>
+              </a:spcAft>
+            </a:pPr>
+            <a:r>
+              <a:rPr sz="1300" b="0">
+                <a:solidFill>
+                  <a:srgbClr val="5A5A5A"/>
+                </a:solidFill>
+                <a:latin typeface="Consolas"/>
+              </a:rPr>
+              <a:t>|</a:t>
+            </a:r>
+          </a:p>
+          <a:p>
+            <a:pPr lvl="1">
+              <a:spcAft>
+                <a:spcPts val="200"/>
+              </a:spcAft>
+            </a:pPr>
+            <a:r>
+              <a:rPr sz="1300" b="0">
+                <a:solidFill>
+                  <a:srgbClr val="5A5A5A"/>
+                </a:solidFill>
+                <a:latin typeface="Consolas"/>
+              </a:rPr>
+              <a:t>v</a:t>
+            </a:r>
+          </a:p>
+          <a:p>
+            <a:pPr>
+              <a:spcAft>
+                <a:spcPts val="200"/>
+              </a:spcAft>
+            </a:pPr>
+            <a:r>
+              <a:rPr sz="1500" b="0">
+                <a:solidFill>
+                  <a:srgbClr val="1A1A1A"/>
+                </a:solidFill>
+                <a:latin typeface="Consolas"/>
+              </a:rPr>
+              <a:t>MatchupTable.xlsx        demand and signal columns BLANK</a:t>
+            </a:r>
+          </a:p>
+        </p:txBody>
+      </p:sp>
+    </p:spTree>
+  </p:cSld>
+  <p:clrMapOvr>
+    <a:masterClrMapping/>
+  </p:clrMapOvr>
+</p:sld>
+</file>
+
+<file path=ppt/slides/slide15.xml><?xml version="1.0" encoding="utf-8"?>
 <p:sld xmlns:a="http://schemas.openxmlformats.org/drawingml/2006/main" xmlns:p="http://schemas.openxmlformats.org/presentationml/2006/main" xmlns:r="http://schemas.openxmlformats.org/officeDocument/2006/relationships">
   <p:cSld>
     <p:spTree>
@@ -5772,7 +7093,7 @@
 </p:sld>
 </file>
 
-<file path=ppt/slides/slide14.xml><?xml version="1.0" encoding="utf-8"?>
+<file path=ppt/slides/slide16.xml><?xml version="1.0" encoding="utf-8"?>
 <p:sld xmlns:a="http://schemas.openxmlformats.org/drawingml/2006/main" xmlns:p="http://schemas.openxmlformats.org/presentationml/2006/main" xmlns:r="http://schemas.openxmlformats.org/officeDocument/2006/relationships">
   <p:cSld>
     <p:spTree>
@@ -5992,7 +7313,7 @@
 </p:sld>
 </file>
 
-<file path=ppt/slides/slide15.xml><?xml version="1.0" encoding="utf-8"?>
+<file path=ppt/slides/slide17.xml><?xml version="1.0" encoding="utf-8"?>
 <p:sld xmlns:a="http://schemas.openxmlformats.org/drawingml/2006/main" xmlns:p="http://schemas.openxmlformats.org/presentationml/2006/main" xmlns:r="http://schemas.openxmlformats.org/officeDocument/2006/relationships">
   <p:cSld>
     <p:spTree>
@@ -6212,7 +7533,7 @@
 </p:sld>
 </file>
 
-<file path=ppt/slides/slide16.xml><?xml version="1.0" encoding="utf-8"?>
+<file path=ppt/slides/slide18.xml><?xml version="1.0" encoding="utf-8"?>
 <p:sld xmlns:a="http://schemas.openxmlformats.org/drawingml/2006/main" xmlns:p="http://schemas.openxmlformats.org/presentationml/2006/main" xmlns:r="http://schemas.openxmlformats.org/officeDocument/2006/relationships">
   <p:cSld>
     <p:spTree>
@@ -6432,7 +7753,7 @@
 </p:sld>
 </file>
 
-<file path=ppt/slides/slide17.xml><?xml version="1.0" encoding="utf-8"?>
+<file path=ppt/slides/slide19.xml><?xml version="1.0" encoding="utf-8"?>
 <p:sld xmlns:a="http://schemas.openxmlformats.org/drawingml/2006/main" xmlns:p="http://schemas.openxmlformats.org/presentationml/2006/main" xmlns:r="http://schemas.openxmlformats.org/officeDocument/2006/relationships">
   <p:cSld>
     <p:spTree>
@@ -7020,7 +8341,7 @@
 </p:sld>
 </file>
 
-<file path=ppt/slides/slide18.xml><?xml version="1.0" encoding="utf-8"?>
+<file path=ppt/slides/slide2.xml><?xml version="1.0" encoding="utf-8"?>
 <p:sld xmlns:a="http://schemas.openxmlformats.org/drawingml/2006/main" xmlns:p="http://schemas.openxmlformats.org/presentationml/2006/main" xmlns:r="http://schemas.openxmlformats.org/officeDocument/2006/relationships">
   <p:cSld>
     <p:spTree>
@@ -7108,7 +8429,7 @@
                 </a:solidFill>
                 <a:latin typeface="Calibri"/>
               </a:rPr>
-              <a:t>They agree</a:t>
+              <a:t>What a MatchupTable is</a:t>
             </a:r>
           </a:p>
         </p:txBody>
@@ -7147,7 +8468,7 @@
                 </a:solidFill>
                 <a:latin typeface="Calibri"/>
               </a:rPr>
-              <a:t>• Junctions        10  =  10</a:t>
+              <a:t>• One row per movement - one line for each turn at each intersection</a:t>
             </a:r>
           </a:p>
           <a:p>
@@ -7163,7 +8484,55 @@
                 </a:solidFill>
                 <a:latin typeface="Calibri"/>
               </a:rPr>
-              <a:t>• Approaches       34  =  34</a:t>
+              <a:t>• It ties three separate worlds together so they can refer to each other:</a:t>
+            </a:r>
+          </a:p>
+          <a:p>
+            <a:pPr lvl="1">
+              <a:spcAft>
+                <a:spcPts val="1000"/>
+              </a:spcAft>
+            </a:pPr>
+            <a:r>
+              <a:rPr sz="1600" b="0">
+                <a:solidFill>
+                  <a:srgbClr val="5A5A5A"/>
+                </a:solidFill>
+                <a:latin typeface="Calibri"/>
+              </a:rPr>
+              <a:t>Network - which road or link the traffic comes from and goes to</a:t>
+            </a:r>
+          </a:p>
+          <a:p>
+            <a:pPr lvl="1">
+              <a:spcAft>
+                <a:spcPts val="1000"/>
+              </a:spcAft>
+            </a:pPr>
+            <a:r>
+              <a:rPr sz="1600" b="0">
+                <a:solidFill>
+                  <a:srgbClr val="5A5A5A"/>
+                </a:solidFill>
+                <a:latin typeface="Calibri"/>
+              </a:rPr>
+              <a:t>Demand - which camera file, and which turn within it</a:t>
+            </a:r>
+          </a:p>
+          <a:p>
+            <a:pPr lvl="1">
+              <a:spcAft>
+                <a:spcPts val="1000"/>
+              </a:spcAft>
+            </a:pPr>
+            <a:r>
+              <a:rPr sz="1600" b="0">
+                <a:solidFill>
+                  <a:srgbClr val="5A5A5A"/>
+                </a:solidFill>
+                <a:latin typeface="Calibri"/>
+              </a:rPr>
+              <a:t>Signal - which Synchro intersection, and which phase</a:t>
             </a:r>
           </a:p>
           <a:p>
@@ -7179,7 +8548,7 @@
                 </a:solidFill>
                 <a:latin typeface="Calibri"/>
               </a:rPr>
-              <a:t>• Movements       104  =  104</a:t>
+              <a:t>• 104 rows for Chattanooga. It is the only file a person edits</a:t>
             </a:r>
           </a:p>
           <a:p>
@@ -7195,39 +8564,7 @@
                 </a:solidFill>
                 <a:latin typeface="Calibri"/>
               </a:rPr>
-              <a:t>• Turn labels     104 / 104 identical</a:t>
-            </a:r>
-          </a:p>
-          <a:p>
-            <a:pPr>
-              <a:spcAft>
-                <a:spcPts val="1000"/>
-              </a:spcAft>
-            </a:pPr>
-            <a:r>
-              <a:rPr sz="1800" b="0">
-                <a:solidFill>
-                  <a:srgbClr val="1A1A1A"/>
-                </a:solidFill>
-                <a:latin typeface="Calibri"/>
-              </a:rPr>
-              <a:t>• Turn mix        thru 30, right 28, left 24, Uturn 22 on both sides</a:t>
-            </a:r>
-          </a:p>
-          <a:p>
-            <a:pPr>
-              <a:spcAft>
-                <a:spcPts val="1000"/>
-              </a:spcAft>
-            </a:pPr>
-            <a:r>
-              <a:rPr sz="1800" b="0">
-                <a:solidFill>
-                  <a:srgbClr val="1A1A1A"/>
-                </a:solidFill>
-                <a:latin typeface="Calibri"/>
-              </a:rPr>
-              <a:t>• Junction mapping confirmed by coordinates - worst separation 1.98 m</a:t>
+              <a:t>• Both pipelines build one. Same purpose, same layout, different ID spaces</a:t>
             </a:r>
           </a:p>
         </p:txBody>
@@ -7240,7 +8577,227 @@
 </p:sld>
 </file>
 
-<file path=ppt/slides/slide19.xml><?xml version="1.0" encoding="utf-8"?>
+<file path=ppt/slides/slide20.xml><?xml version="1.0" encoding="utf-8"?>
+<p:sld xmlns:a="http://schemas.openxmlformats.org/drawingml/2006/main" xmlns:p="http://schemas.openxmlformats.org/presentationml/2006/main" xmlns:r="http://schemas.openxmlformats.org/officeDocument/2006/relationships">
+  <p:cSld>
+    <p:spTree>
+      <p:nvGrpSpPr>
+        <p:cNvPr id="1" name=""/>
+        <p:cNvGrpSpPr/>
+        <p:nvPr/>
+      </p:nvGrpSpPr>
+      <p:grpSpPr/>
+      <p:sp>
+        <p:nvSpPr>
+          <p:cNvPr id="2" name="Rectangle 1"/>
+          <p:cNvSpPr/>
+          <p:nvPr/>
+        </p:nvSpPr>
+        <p:spPr>
+          <a:xfrm>
+            <a:off x="0" y="0"/>
+            <a:ext cx="12191695" cy="1005840"/>
+          </a:xfrm>
+          <a:prstGeom prst="rect">
+            <a:avLst/>
+          </a:prstGeom>
+          <a:solidFill>
+            <a:srgbClr val="14375E"/>
+          </a:solidFill>
+          <a:ln>
+            <a:noFill/>
+          </a:ln>
+          <a:effectLst/>
+        </p:spPr>
+        <p:style>
+          <a:lnRef idx="1">
+            <a:schemeClr val="accent1"/>
+          </a:lnRef>
+          <a:fillRef idx="3">
+            <a:schemeClr val="accent1"/>
+          </a:fillRef>
+          <a:effectRef idx="2">
+            <a:schemeClr val="accent1"/>
+          </a:effectRef>
+          <a:fontRef idx="minor">
+            <a:schemeClr val="lt1"/>
+          </a:fontRef>
+        </p:style>
+        <p:txBody>
+          <a:bodyPr rtlCol="0" anchor="ctr"/>
+          <a:lstStyle/>
+          <a:p>
+            <a:pPr algn="ctr"/>
+          </a:p>
+        </p:txBody>
+      </p:sp>
+      <p:sp>
+        <p:nvSpPr>
+          <p:cNvPr id="3" name="TextBox 2"/>
+          <p:cNvSpPr txBox="1"/>
+          <p:nvPr/>
+        </p:nvSpPr>
+        <p:spPr>
+          <a:xfrm>
+            <a:off x="457200" y="164592"/>
+            <a:ext cx="11247120" cy="731520"/>
+          </a:xfrm>
+          <a:prstGeom prst="rect">
+            <a:avLst/>
+          </a:prstGeom>
+          <a:noFill/>
+        </p:spPr>
+        <p:txBody>
+          <a:bodyPr wrap="square">
+            <a:spAutoFit/>
+          </a:bodyPr>
+          <a:lstStyle/>
+          <a:p>
+            <a:pPr>
+              <a:spcAft>
+                <a:spcPts val="1000"/>
+              </a:spcAft>
+            </a:pPr>
+            <a:r>
+              <a:rPr sz="2600" b="1">
+                <a:solidFill>
+                  <a:srgbClr val="FFFFFF"/>
+                </a:solidFill>
+                <a:latin typeface="Calibri"/>
+              </a:rPr>
+              <a:t>They agree</a:t>
+            </a:r>
+          </a:p>
+        </p:txBody>
+      </p:sp>
+      <p:sp>
+        <p:nvSpPr>
+          <p:cNvPr id="4" name="TextBox 3"/>
+          <p:cNvSpPr txBox="1"/>
+          <p:nvPr/>
+        </p:nvSpPr>
+        <p:spPr>
+          <a:xfrm>
+            <a:off x="640080" y="1325880"/>
+            <a:ext cx="10972800" cy="5120640"/>
+          </a:xfrm>
+          <a:prstGeom prst="rect">
+            <a:avLst/>
+          </a:prstGeom>
+          <a:noFill/>
+        </p:spPr>
+        <p:txBody>
+          <a:bodyPr wrap="square">
+            <a:spAutoFit/>
+          </a:bodyPr>
+          <a:lstStyle/>
+          <a:p>
+            <a:pPr>
+              <a:spcAft>
+                <a:spcPts val="1000"/>
+              </a:spcAft>
+            </a:pPr>
+            <a:r>
+              <a:rPr sz="1800" b="0">
+                <a:solidFill>
+                  <a:srgbClr val="1A1A1A"/>
+                </a:solidFill>
+                <a:latin typeface="Calibri"/>
+              </a:rPr>
+              <a:t>• Junctions        10  =  10</a:t>
+            </a:r>
+          </a:p>
+          <a:p>
+            <a:pPr>
+              <a:spcAft>
+                <a:spcPts val="1000"/>
+              </a:spcAft>
+            </a:pPr>
+            <a:r>
+              <a:rPr sz="1800" b="0">
+                <a:solidFill>
+                  <a:srgbClr val="1A1A1A"/>
+                </a:solidFill>
+                <a:latin typeface="Calibri"/>
+              </a:rPr>
+              <a:t>• Approaches       34  =  34</a:t>
+            </a:r>
+          </a:p>
+          <a:p>
+            <a:pPr>
+              <a:spcAft>
+                <a:spcPts val="1000"/>
+              </a:spcAft>
+            </a:pPr>
+            <a:r>
+              <a:rPr sz="1800" b="0">
+                <a:solidFill>
+                  <a:srgbClr val="1A1A1A"/>
+                </a:solidFill>
+                <a:latin typeface="Calibri"/>
+              </a:rPr>
+              <a:t>• Movements       104  =  104</a:t>
+            </a:r>
+          </a:p>
+          <a:p>
+            <a:pPr>
+              <a:spcAft>
+                <a:spcPts val="1000"/>
+              </a:spcAft>
+            </a:pPr>
+            <a:r>
+              <a:rPr sz="1800" b="0">
+                <a:solidFill>
+                  <a:srgbClr val="1A1A1A"/>
+                </a:solidFill>
+                <a:latin typeface="Calibri"/>
+              </a:rPr>
+              <a:t>• Turn labels     104 / 104 identical</a:t>
+            </a:r>
+          </a:p>
+          <a:p>
+            <a:pPr>
+              <a:spcAft>
+                <a:spcPts val="1000"/>
+              </a:spcAft>
+            </a:pPr>
+            <a:r>
+              <a:rPr sz="1800" b="0">
+                <a:solidFill>
+                  <a:srgbClr val="1A1A1A"/>
+                </a:solidFill>
+                <a:latin typeface="Calibri"/>
+              </a:rPr>
+              <a:t>• Turn mix        thru 30, right 28, left 24, Uturn 22 on both sides</a:t>
+            </a:r>
+          </a:p>
+          <a:p>
+            <a:pPr>
+              <a:spcAft>
+                <a:spcPts val="1000"/>
+              </a:spcAft>
+            </a:pPr>
+            <a:r>
+              <a:rPr sz="1800" b="0">
+                <a:solidFill>
+                  <a:srgbClr val="1A1A1A"/>
+                </a:solidFill>
+                <a:latin typeface="Calibri"/>
+              </a:rPr>
+              <a:t>• Junction mapping confirmed by coordinates - worst separation 1.98 m</a:t>
+            </a:r>
+          </a:p>
+        </p:txBody>
+      </p:sp>
+    </p:spTree>
+  </p:cSld>
+  <p:clrMapOvr>
+    <a:masterClrMapping/>
+  </p:clrMapOvr>
+</p:sld>
+</file>
+
+<file path=ppt/slides/slide21.xml><?xml version="1.0" encoding="utf-8"?>
 <p:sld xmlns:a="http://schemas.openxmlformats.org/drawingml/2006/main" xmlns:p="http://schemas.openxmlformats.org/presentationml/2006/main" xmlns:r="http://schemas.openxmlformats.org/officeDocument/2006/relationships">
   <p:cSld>
     <p:spTree>
@@ -7595,242 +9152,6 @@
           </a:graphicData>
         </a:graphic>
       </p:graphicFrame>
-    </p:spTree>
-  </p:cSld>
-  <p:clrMapOvr>
-    <a:masterClrMapping/>
-  </p:clrMapOvr>
-</p:sld>
-</file>
-
-<file path=ppt/slides/slide2.xml><?xml version="1.0" encoding="utf-8"?>
-<p:sld xmlns:a="http://schemas.openxmlformats.org/drawingml/2006/main" xmlns:p="http://schemas.openxmlformats.org/presentationml/2006/main" xmlns:r="http://schemas.openxmlformats.org/officeDocument/2006/relationships">
-  <p:cSld>
-    <p:spTree>
-      <p:nvGrpSpPr>
-        <p:cNvPr id="1" name=""/>
-        <p:cNvGrpSpPr/>
-        <p:nvPr/>
-      </p:nvGrpSpPr>
-      <p:grpSpPr/>
-      <p:sp>
-        <p:nvSpPr>
-          <p:cNvPr id="2" name="Rectangle 1"/>
-          <p:cNvSpPr/>
-          <p:nvPr/>
-        </p:nvSpPr>
-        <p:spPr>
-          <a:xfrm>
-            <a:off x="0" y="0"/>
-            <a:ext cx="12191695" cy="1005840"/>
-          </a:xfrm>
-          <a:prstGeom prst="rect">
-            <a:avLst/>
-          </a:prstGeom>
-          <a:solidFill>
-            <a:srgbClr val="14375E"/>
-          </a:solidFill>
-          <a:ln>
-            <a:noFill/>
-          </a:ln>
-          <a:effectLst/>
-        </p:spPr>
-        <p:style>
-          <a:lnRef idx="1">
-            <a:schemeClr val="accent1"/>
-          </a:lnRef>
-          <a:fillRef idx="3">
-            <a:schemeClr val="accent1"/>
-          </a:fillRef>
-          <a:effectRef idx="2">
-            <a:schemeClr val="accent1"/>
-          </a:effectRef>
-          <a:fontRef idx="minor">
-            <a:schemeClr val="lt1"/>
-          </a:fontRef>
-        </p:style>
-        <p:txBody>
-          <a:bodyPr rtlCol="0" anchor="ctr"/>
-          <a:lstStyle/>
-          <a:p>
-            <a:pPr algn="ctr"/>
-          </a:p>
-        </p:txBody>
-      </p:sp>
-      <p:sp>
-        <p:nvSpPr>
-          <p:cNvPr id="3" name="TextBox 2"/>
-          <p:cNvSpPr txBox="1"/>
-          <p:nvPr/>
-        </p:nvSpPr>
-        <p:spPr>
-          <a:xfrm>
-            <a:off x="457200" y="164592"/>
-            <a:ext cx="11247120" cy="731520"/>
-          </a:xfrm>
-          <a:prstGeom prst="rect">
-            <a:avLst/>
-          </a:prstGeom>
-          <a:noFill/>
-        </p:spPr>
-        <p:txBody>
-          <a:bodyPr wrap="square">
-            <a:spAutoFit/>
-          </a:bodyPr>
-          <a:lstStyle/>
-          <a:p>
-            <a:pPr>
-              <a:spcAft>
-                <a:spcPts val="1000"/>
-              </a:spcAft>
-            </a:pPr>
-            <a:r>
-              <a:rPr sz="2600" b="1">
-                <a:solidFill>
-                  <a:srgbClr val="FFFFFF"/>
-                </a:solidFill>
-                <a:latin typeface="Calibri"/>
-              </a:rPr>
-              <a:t>What a MatchupTable is</a:t>
-            </a:r>
-          </a:p>
-        </p:txBody>
-      </p:sp>
-      <p:sp>
-        <p:nvSpPr>
-          <p:cNvPr id="4" name="TextBox 3"/>
-          <p:cNvSpPr txBox="1"/>
-          <p:nvPr/>
-        </p:nvSpPr>
-        <p:spPr>
-          <a:xfrm>
-            <a:off x="640080" y="1325880"/>
-            <a:ext cx="10972800" cy="5120640"/>
-          </a:xfrm>
-          <a:prstGeom prst="rect">
-            <a:avLst/>
-          </a:prstGeom>
-          <a:noFill/>
-        </p:spPr>
-        <p:txBody>
-          <a:bodyPr wrap="square">
-            <a:spAutoFit/>
-          </a:bodyPr>
-          <a:lstStyle/>
-          <a:p>
-            <a:pPr>
-              <a:spcAft>
-                <a:spcPts val="1000"/>
-              </a:spcAft>
-            </a:pPr>
-            <a:r>
-              <a:rPr sz="1800" b="0">
-                <a:solidFill>
-                  <a:srgbClr val="1A1A1A"/>
-                </a:solidFill>
-                <a:latin typeface="Calibri"/>
-              </a:rPr>
-              <a:t>• One row per movement - one line for each turn at each intersection</a:t>
-            </a:r>
-          </a:p>
-          <a:p>
-            <a:pPr>
-              <a:spcAft>
-                <a:spcPts val="1000"/>
-              </a:spcAft>
-            </a:pPr>
-            <a:r>
-              <a:rPr sz="1800" b="0">
-                <a:solidFill>
-                  <a:srgbClr val="1A1A1A"/>
-                </a:solidFill>
-                <a:latin typeface="Calibri"/>
-              </a:rPr>
-              <a:t>• It ties three separate worlds together so they can refer to each other:</a:t>
-            </a:r>
-          </a:p>
-          <a:p>
-            <a:pPr lvl="1">
-              <a:spcAft>
-                <a:spcPts val="1000"/>
-              </a:spcAft>
-            </a:pPr>
-            <a:r>
-              <a:rPr sz="1600" b="0">
-                <a:solidFill>
-                  <a:srgbClr val="5A5A5A"/>
-                </a:solidFill>
-                <a:latin typeface="Calibri"/>
-              </a:rPr>
-              <a:t>Network - which road or link the traffic comes from and goes to</a:t>
-            </a:r>
-          </a:p>
-          <a:p>
-            <a:pPr lvl="1">
-              <a:spcAft>
-                <a:spcPts val="1000"/>
-              </a:spcAft>
-            </a:pPr>
-            <a:r>
-              <a:rPr sz="1600" b="0">
-                <a:solidFill>
-                  <a:srgbClr val="5A5A5A"/>
-                </a:solidFill>
-                <a:latin typeface="Calibri"/>
-              </a:rPr>
-              <a:t>Demand - which camera file, and which turn within it</a:t>
-            </a:r>
-          </a:p>
-          <a:p>
-            <a:pPr lvl="1">
-              <a:spcAft>
-                <a:spcPts val="1000"/>
-              </a:spcAft>
-            </a:pPr>
-            <a:r>
-              <a:rPr sz="1600" b="0">
-                <a:solidFill>
-                  <a:srgbClr val="5A5A5A"/>
-                </a:solidFill>
-                <a:latin typeface="Calibri"/>
-              </a:rPr>
-              <a:t>Signal - which Synchro intersection, and which phase</a:t>
-            </a:r>
-          </a:p>
-          <a:p>
-            <a:pPr>
-              <a:spcAft>
-                <a:spcPts val="1000"/>
-              </a:spcAft>
-            </a:pPr>
-            <a:r>
-              <a:rPr sz="1800" b="0">
-                <a:solidFill>
-                  <a:srgbClr val="1A1A1A"/>
-                </a:solidFill>
-                <a:latin typeface="Calibri"/>
-              </a:rPr>
-              <a:t>• 104 rows for Chattanooga. It is the only file a person edits</a:t>
-            </a:r>
-          </a:p>
-          <a:p>
-            <a:pPr>
-              <a:spcAft>
-                <a:spcPts val="1000"/>
-              </a:spcAft>
-            </a:pPr>
-            <a:r>
-              <a:rPr sz="1800" b="0">
-                <a:solidFill>
-                  <a:srgbClr val="1A1A1A"/>
-                </a:solidFill>
-                <a:latin typeface="Calibri"/>
-              </a:rPr>
-              <a:t>• Both pipelines build one. Same purpose, same layout, different ID spaces</a:t>
-            </a:r>
-          </a:p>
-        </p:txBody>
-      </p:sp>
     </p:spTree>
   </p:cSld>
   <p:clrMapOvr>

</xml_diff>